<commit_message>
added string function practice questions
</commit_message>
<xml_diff>
--- a/lecture_notes/chapter8/chapter8.pptx
+++ b/lecture_notes/chapter8/chapter8.pptx
@@ -137,7 +137,7 @@
 <file path=ppt/revisionInfo.xml><?xml version="1.0" encoding="utf-8"?>
 <p1510:revInfo xmlns:a="http://schemas.openxmlformats.org/drawingml/2006/main" xmlns:r="http://schemas.openxmlformats.org/officeDocument/2006/relationships" xmlns:p1510="http://schemas.microsoft.com/office/powerpoint/2015/10/main">
   <p1510:revLst>
-    <p1510:client id="{97BF8AC8-632D-AA41-A58B-5F24C449E77A}" v="7" dt="2026-03-06T18:19:33.177"/>
+    <p1510:client id="{97BF8AC8-632D-AA41-A58B-5F24C449E77A}" v="8" dt="2026-03-09T16:44:50.065"/>
   </p1510:revLst>
 </p1510:revInfo>
 </file>
@@ -147,7 +147,7 @@
   <pc:docChgLst>
     <pc:chgData name="Toby Donaldson" userId="2e6e5431-bb17-4c41-9985-d39c50d83c73" providerId="ADAL" clId="{F31BC264-820E-54C4-A6D1-F92AF9CC222E}"/>
     <pc:docChg chg="undo custSel addSld delSld modSld sldOrd">
-      <pc:chgData name="Toby Donaldson" userId="2e6e5431-bb17-4c41-9985-d39c50d83c73" providerId="ADAL" clId="{F31BC264-820E-54C4-A6D1-F92AF9CC222E}" dt="2026-03-06T18:19:33.177" v="17"/>
+      <pc:chgData name="Toby Donaldson" userId="2e6e5431-bb17-4c41-9985-d39c50d83c73" providerId="ADAL" clId="{F31BC264-820E-54C4-A6D1-F92AF9CC222E}" dt="2026-03-09T16:44:50.063" v="18"/>
       <pc:docMkLst>
         <pc:docMk/>
       </pc:docMkLst>
@@ -178,14 +178,6 @@
             <pc:docMk/>
             <pc:sldMk cId="0" sldId="258"/>
             <ac:spMk id="9" creationId="{00000000-0000-0000-0000-000000000000}"/>
-          </ac:spMkLst>
-        </pc:spChg>
-        <pc:spChg chg="del">
-          <ac:chgData name="Toby Donaldson" userId="2e6e5431-bb17-4c41-9985-d39c50d83c73" providerId="ADAL" clId="{F31BC264-820E-54C4-A6D1-F92AF9CC222E}" dt="2026-03-06T17:15:34.232" v="9" actId="21"/>
-          <ac:spMkLst>
-            <pc:docMk/>
-            <pc:sldMk cId="0" sldId="258"/>
-            <ac:spMk id="10" creationId="{00000000-0000-0000-0000-000000000000}"/>
           </ac:spMkLst>
         </pc:spChg>
       </pc:sldChg>
@@ -220,7 +212,22 @@
         </pc:inkChg>
       </pc:sldChg>
       <pc:sldChg chg="addSp">
-        <pc:chgData name="Toby Donaldson" userId="2e6e5431-bb17-4c41-9985-d39c50d83c73" providerId="ADAL" clId="{F31BC264-820E-54C4-A6D1-F92AF9CC222E}" dt="2026-03-06T17:45:52.077" v="13"/>
+        <pc:chgData name="Toby Donaldson" userId="2e6e5431-bb17-4c41-9985-d39c50d83c73" providerId="ADAL" clId="{F31BC264-820E-54C4-A6D1-F92AF9CC222E}" dt="2026-03-09T16:44:50.063" v="18"/>
+        <pc:sldMkLst>
+          <pc:docMk/>
+          <pc:sldMk cId="0" sldId="262"/>
+        </pc:sldMkLst>
+        <pc:inkChg chg="add">
+          <ac:chgData name="Toby Donaldson" userId="2e6e5431-bb17-4c41-9985-d39c50d83c73" providerId="ADAL" clId="{F31BC264-820E-54C4-A6D1-F92AF9CC222E}" dt="2026-03-09T16:44:50.063" v="18"/>
+          <ac:inkMkLst>
+            <pc:docMk/>
+            <pc:sldMk cId="0" sldId="262"/>
+            <ac:inkMk id="9" creationId="{AC7BE911-08F2-CEA2-B469-FE13315A8543}"/>
+          </ac:inkMkLst>
+        </pc:inkChg>
+      </pc:sldChg>
+      <pc:sldChg chg="addSp">
+        <pc:chgData name="Toby Donaldson" userId="2e6e5431-bb17-4c41-9985-d39c50d83c73" providerId="ADAL" clId="{F31BC264-820E-54C4-A6D1-F92AF9CC222E}" dt="2026-03-09T16:44:50.063" v="18"/>
         <pc:sldMkLst>
           <pc:docMk/>
           <pc:sldMk cId="0" sldId="263"/>
@@ -233,9 +240,17 @@
             <ac:inkMk id="18" creationId="{BE036126-603B-026E-01A3-1C98FE5AC763}"/>
           </ac:inkMkLst>
         </pc:inkChg>
+        <pc:inkChg chg="add">
+          <ac:chgData name="Toby Donaldson" userId="2e6e5431-bb17-4c41-9985-d39c50d83c73" providerId="ADAL" clId="{F31BC264-820E-54C4-A6D1-F92AF9CC222E}" dt="2026-03-09T16:44:50.063" v="18"/>
+          <ac:inkMkLst>
+            <pc:docMk/>
+            <pc:sldMk cId="0" sldId="263"/>
+            <ac:inkMk id="19" creationId="{5129E02F-C7EA-487F-74BE-96C2F5D0AE19}"/>
+          </ac:inkMkLst>
+        </pc:inkChg>
       </pc:sldChg>
       <pc:sldChg chg="addSp">
-        <pc:chgData name="Toby Donaldson" userId="2e6e5431-bb17-4c41-9985-d39c50d83c73" providerId="ADAL" clId="{F31BC264-820E-54C4-A6D1-F92AF9CC222E}" dt="2026-03-06T17:45:52.077" v="13"/>
+        <pc:chgData name="Toby Donaldson" userId="2e6e5431-bb17-4c41-9985-d39c50d83c73" providerId="ADAL" clId="{F31BC264-820E-54C4-A6D1-F92AF9CC222E}" dt="2026-03-09T16:44:50.063" v="18"/>
         <pc:sldMkLst>
           <pc:docMk/>
           <pc:sldMk cId="0" sldId="264"/>
@@ -248,9 +263,17 @@
             <ac:inkMk id="9" creationId="{D5222684-69EA-7639-B1E5-F509D280C7AB}"/>
           </ac:inkMkLst>
         </pc:inkChg>
+        <pc:inkChg chg="add">
+          <ac:chgData name="Toby Donaldson" userId="2e6e5431-bb17-4c41-9985-d39c50d83c73" providerId="ADAL" clId="{F31BC264-820E-54C4-A6D1-F92AF9CC222E}" dt="2026-03-09T16:44:50.063" v="18"/>
+          <ac:inkMkLst>
+            <pc:docMk/>
+            <pc:sldMk cId="0" sldId="264"/>
+            <ac:inkMk id="13" creationId="{EAAA24B4-E491-4956-13E3-5E7AE1EEF807}"/>
+          </ac:inkMkLst>
+        </pc:inkChg>
       </pc:sldChg>
       <pc:sldChg chg="addSp">
-        <pc:chgData name="Toby Donaldson" userId="2e6e5431-bb17-4c41-9985-d39c50d83c73" providerId="ADAL" clId="{F31BC264-820E-54C4-A6D1-F92AF9CC222E}" dt="2026-03-06T17:48:59.027" v="14"/>
+        <pc:chgData name="Toby Donaldson" userId="2e6e5431-bb17-4c41-9985-d39c50d83c73" providerId="ADAL" clId="{F31BC264-820E-54C4-A6D1-F92AF9CC222E}" dt="2026-03-09T16:44:50.063" v="18"/>
         <pc:sldMkLst>
           <pc:docMk/>
           <pc:sldMk cId="0" sldId="266"/>
@@ -261,6 +284,14 @@
             <pc:docMk/>
             <pc:sldMk cId="0" sldId="266"/>
             <ac:inkMk id="10" creationId="{CB145FEE-1C36-D6AB-389A-70208BB4FD29}"/>
+          </ac:inkMkLst>
+        </pc:inkChg>
+        <pc:inkChg chg="add">
+          <ac:chgData name="Toby Donaldson" userId="2e6e5431-bb17-4c41-9985-d39c50d83c73" providerId="ADAL" clId="{F31BC264-820E-54C4-A6D1-F92AF9CC222E}" dt="2026-03-09T16:44:50.063" v="18"/>
+          <ac:inkMkLst>
+            <pc:docMk/>
+            <pc:sldMk cId="0" sldId="266"/>
+            <ac:inkMk id="14" creationId="{7AD861A7-21C7-3349-981F-691177BFFE29}"/>
           </ac:inkMkLst>
         </pc:inkChg>
       </pc:sldChg>
@@ -280,7 +311,7 @@
         </pc:inkChg>
       </pc:sldChg>
       <pc:sldChg chg="addSp">
-        <pc:chgData name="Toby Donaldson" userId="2e6e5431-bb17-4c41-9985-d39c50d83c73" providerId="ADAL" clId="{F31BC264-820E-54C4-A6D1-F92AF9CC222E}" dt="2026-03-06T18:15:26.306" v="16"/>
+        <pc:chgData name="Toby Donaldson" userId="2e6e5431-bb17-4c41-9985-d39c50d83c73" providerId="ADAL" clId="{F31BC264-820E-54C4-A6D1-F92AF9CC222E}" dt="2026-03-09T16:44:50.063" v="18"/>
         <pc:sldMkLst>
           <pc:docMk/>
           <pc:sldMk cId="0" sldId="269"/>
@@ -293,9 +324,17 @@
             <ac:inkMk id="15" creationId="{8BDE4D2D-8155-74DB-17B7-F8B36B74F4CE}"/>
           </ac:inkMkLst>
         </pc:inkChg>
+        <pc:inkChg chg="add">
+          <ac:chgData name="Toby Donaldson" userId="2e6e5431-bb17-4c41-9985-d39c50d83c73" providerId="ADAL" clId="{F31BC264-820E-54C4-A6D1-F92AF9CC222E}" dt="2026-03-09T16:44:50.063" v="18"/>
+          <ac:inkMkLst>
+            <pc:docMk/>
+            <pc:sldMk cId="0" sldId="269"/>
+            <ac:inkMk id="19" creationId="{E3572BDD-5ABF-438D-2C34-EF49AA69075D}"/>
+          </ac:inkMkLst>
+        </pc:inkChg>
       </pc:sldChg>
       <pc:sldChg chg="addSp">
-        <pc:chgData name="Toby Donaldson" userId="2e6e5431-bb17-4c41-9985-d39c50d83c73" providerId="ADAL" clId="{F31BC264-820E-54C4-A6D1-F92AF9CC222E}" dt="2026-03-06T18:19:33.177" v="17"/>
+        <pc:chgData name="Toby Donaldson" userId="2e6e5431-bb17-4c41-9985-d39c50d83c73" providerId="ADAL" clId="{F31BC264-820E-54C4-A6D1-F92AF9CC222E}" dt="2026-03-09T16:44:50.063" v="18"/>
         <pc:sldMkLst>
           <pc:docMk/>
           <pc:sldMk cId="0" sldId="271"/>
@@ -306,6 +345,59 @@
             <pc:docMk/>
             <pc:sldMk cId="0" sldId="271"/>
             <ac:inkMk id="56" creationId="{13098AC2-512A-0948-C1B4-A508ECACA6AA}"/>
+          </ac:inkMkLst>
+        </pc:inkChg>
+        <pc:inkChg chg="add">
+          <ac:chgData name="Toby Donaldson" userId="2e6e5431-bb17-4c41-9985-d39c50d83c73" providerId="ADAL" clId="{F31BC264-820E-54C4-A6D1-F92AF9CC222E}" dt="2026-03-09T16:44:50.063" v="18"/>
+          <ac:inkMkLst>
+            <pc:docMk/>
+            <pc:sldMk cId="0" sldId="271"/>
+            <ac:inkMk id="57" creationId="{9A8F4B0D-A76E-756F-5475-DEA03395924A}"/>
+          </ac:inkMkLst>
+        </pc:inkChg>
+      </pc:sldChg>
+      <pc:sldChg chg="addSp">
+        <pc:chgData name="Toby Donaldson" userId="2e6e5431-bb17-4c41-9985-d39c50d83c73" providerId="ADAL" clId="{F31BC264-820E-54C4-A6D1-F92AF9CC222E}" dt="2026-03-09T16:44:50.063" v="18"/>
+        <pc:sldMkLst>
+          <pc:docMk/>
+          <pc:sldMk cId="0" sldId="273"/>
+        </pc:sldMkLst>
+        <pc:inkChg chg="add">
+          <ac:chgData name="Toby Donaldson" userId="2e6e5431-bb17-4c41-9985-d39c50d83c73" providerId="ADAL" clId="{F31BC264-820E-54C4-A6D1-F92AF9CC222E}" dt="2026-03-09T16:44:50.063" v="18"/>
+          <ac:inkMkLst>
+            <pc:docMk/>
+            <pc:sldMk cId="0" sldId="273"/>
+            <ac:inkMk id="24" creationId="{E904D170-2237-656C-548A-35219327E92A}"/>
+          </ac:inkMkLst>
+        </pc:inkChg>
+      </pc:sldChg>
+      <pc:sldChg chg="addSp">
+        <pc:chgData name="Toby Donaldson" userId="2e6e5431-bb17-4c41-9985-d39c50d83c73" providerId="ADAL" clId="{F31BC264-820E-54C4-A6D1-F92AF9CC222E}" dt="2026-03-09T16:44:50.063" v="18"/>
+        <pc:sldMkLst>
+          <pc:docMk/>
+          <pc:sldMk cId="0" sldId="274"/>
+        </pc:sldMkLst>
+        <pc:inkChg chg="add">
+          <ac:chgData name="Toby Donaldson" userId="2e6e5431-bb17-4c41-9985-d39c50d83c73" providerId="ADAL" clId="{F31BC264-820E-54C4-A6D1-F92AF9CC222E}" dt="2026-03-09T16:44:50.063" v="18"/>
+          <ac:inkMkLst>
+            <pc:docMk/>
+            <pc:sldMk cId="0" sldId="274"/>
+            <ac:inkMk id="9" creationId="{1224DAB0-4ED3-A392-16FF-892C26240B54}"/>
+          </ac:inkMkLst>
+        </pc:inkChg>
+      </pc:sldChg>
+      <pc:sldChg chg="addSp">
+        <pc:chgData name="Toby Donaldson" userId="2e6e5431-bb17-4c41-9985-d39c50d83c73" providerId="ADAL" clId="{F31BC264-820E-54C4-A6D1-F92AF9CC222E}" dt="2026-03-09T16:44:50.063" v="18"/>
+        <pc:sldMkLst>
+          <pc:docMk/>
+          <pc:sldMk cId="0" sldId="275"/>
+        </pc:sldMkLst>
+        <pc:inkChg chg="add">
+          <ac:chgData name="Toby Donaldson" userId="2e6e5431-bb17-4c41-9985-d39c50d83c73" providerId="ADAL" clId="{F31BC264-820E-54C4-A6D1-F92AF9CC222E}" dt="2026-03-09T16:44:50.063" v="18"/>
+          <ac:inkMkLst>
+            <pc:docMk/>
+            <pc:sldMk cId="0" sldId="275"/>
+            <ac:inkMk id="5" creationId="{7A369A67-4C74-B2D0-B0B4-512D2C96AB8D}"/>
           </ac:inkMkLst>
         </pc:inkChg>
       </pc:sldChg>
@@ -321,14 +413,6 @@
             <pc:docMk/>
             <pc:sldMk cId="3014672128" sldId="276"/>
             <ac:spMk id="9" creationId="{075091F9-7E6A-90AE-C1A1-D01D477FF50A}"/>
-          </ac:spMkLst>
-        </pc:spChg>
-        <pc:spChg chg="del">
-          <ac:chgData name="Toby Donaldson" userId="2e6e5431-bb17-4c41-9985-d39c50d83c73" providerId="ADAL" clId="{F31BC264-820E-54C4-A6D1-F92AF9CC222E}" dt="2026-03-06T17:15:39.118" v="10" actId="21"/>
-          <ac:spMkLst>
-            <pc:docMk/>
-            <pc:sldMk cId="3014672128" sldId="276"/>
-            <ac:spMk id="10" creationId="{D20F3DFB-CEDD-38C6-3A16-B0B29D1A7BF2}"/>
           </ac:spMkLst>
         </pc:spChg>
         <pc:inkChg chg="add">
@@ -960,6 +1044,157 @@
           <inkml:channelProperty channel="F" name="resolution" value="0" units="1/dev"/>
         </inkml:channelProperties>
       </inkml:inkSource>
+      <inkml:timestamp xml:id="ts0" timeString="2026-03-06T17:48:01.668"/>
+    </inkml:context>
+    <inkml:brush xml:id="br0">
+      <inkml:brushProperty name="width" value="0.05292" units="cm"/>
+      <inkml:brushProperty name="height" value="0.05292" units="cm"/>
+      <inkml:brushProperty name="color" value="#FF0000"/>
+    </inkml:brush>
+  </inkml:definitions>
+  <inkml:trace contextRef="#ctx0" brushRef="#br0">1442 5001 24575,'34'0'0,"-11"0"0,5 0 0,0 0 0,7 0 0,1 0 0,2 0-820,-2 0 1,2 0 0,0 0 0,0 0 667,-3 0 0,1 0 1,-1 0-1,0 0 152,1 0 0,0 0 0,-1 0 0,-2 0 239,-6 0 1,-1 0 0,0 0-240,6 0 0,0 0 0,-2 0 0,1 0 0,-2 0 0,5 0 0,-2 0 371,-7 0 0,-1 0-371,-1 0 0,-2 0 0,11 0 0,-12 0 0,0 0 1001,5 0 0,3 0-1001,1 0 0,2 0 0,-1 0 0,-2 0 0,0 0 0,2 0 0,3 0 0,-5 0 421,3 0-421,-7 0 0,2 0 0,2 0 0,1 0 0,-1 0 0,1 0 0,0 0 0,1 0 0,1 0 0,-1 0 0,1 0 0,0 0 0,-3 0 0,0 0 0,1 0 0,0 0 0,7 0 0,0 0 0,0 0 0,2 0 0,-1 0 0,-1 0 0,-8 0 0,-1 0 0,-2 0 0,6 0 0,-1 0 0,3 0 0,-5 0 0,-8 0 0,0 0 0,1 0 0,-1 0 0,13 0 0,3 0 0,-5 0 0,-1 0 0,1 0 0,-2 0 0,0 0 0,-29 0 0</inkml:trace>
+  <inkml:trace contextRef="#ctx0" brushRef="#br0" timeOffset="15616">979 10319 24575,'22'0'0,"0"0"0,2 0 0,1 0 0,4 0 0,2 0 0,1 0 0,1 0 0,2 0 0,2 0-229,-11 0 0,1 0 0,0 0 229,0 0 0,0 0 0,0 0 0,-1 0 0,0 0 0,0 0 0,4 0 0,1 0 0,-2 0 0,1 0 0,0 0 84,5 0 1,-1 0-85,-8 0 0,-2 0 0,0 0 0,1 0 0,-1 0 0,0 0 0,2 0 0,-2 0 0,4 0 259,-4 0 0,2 0-259,-5 0 0,1 0 0,3 0 0,3 0 0,1 0 0,3 0 0,1 0 0,2 0 0,-7 0 0,2 0 0,1 0 0,0 0 0,0 0 0,1 0 0,-1 0 0,0 0 0,1 0 0,0 0 0,-1 0 0,1 0 0,0 0 0,0 0 0,-1 0 0,1 0 0,1 0 0,-1 0 0,-2 0 0,-2 0 0,1 0 0,-3 0 0,1 0 0,8 0 0,1 0 0,-4 0 0,-8 0 0,0 0 0,4 0 0,3 0 0,0 0 0,2 0 0,1 0 0,0 0 0,-4 0 0,0 0 0,1 0 0,-1 0 0,0 0 0,1 0 0,-1 0 0,-2 0 0,-1 0 0,-2 0 0,0 0 0,8 0 0,-5 0 0,-13 0 0,-3 0 0,-12 0 0</inkml:trace>
+</inkml:ink>
+</file>
+
+<file path=ppt/ink/ink11.xml><?xml version="1.0" encoding="utf-8"?>
+<inkml:ink xmlns:inkml="http://www.w3.org/2003/InkML">
+  <inkml:definitions>
+    <inkml:context xml:id="ctx0">
+      <inkml:inkSource xml:id="inkSrc0">
+        <inkml:traceFormat>
+          <inkml:channel name="X" type="integer" min="-2.14748E9" max="2.14748E9" units="cm"/>
+          <inkml:channel name="Y" type="integer" min="-2.14748E9" max="2.14748E9" units="cm"/>
+          <inkml:channel name="F" type="integer" max="32767" units="dev"/>
+        </inkml:traceFormat>
+        <inkml:channelProperties>
+          <inkml:channelProperty channel="X" name="resolution" value="1000" units="1/cm"/>
+          <inkml:channelProperty channel="Y" name="resolution" value="1000" units="1/cm"/>
+          <inkml:channelProperty channel="F" name="resolution" value="0" units="1/dev"/>
+        </inkml:channelProperties>
+      </inkml:inkSource>
+      <inkml:timestamp xml:id="ts0" timeString="2026-03-09T16:34:14.812"/>
+    </inkml:context>
+    <inkml:brush xml:id="br0">
+      <inkml:brushProperty name="width" value="0.05292" units="cm"/>
+      <inkml:brushProperty name="height" value="0.05292" units="cm"/>
+      <inkml:brushProperty name="color" value="#FF0000"/>
+    </inkml:brush>
+  </inkml:definitions>
+  <inkml:trace contextRef="#ctx0" brushRef="#br0">1508 4974 24575,'32'0'0,"-1"0"0,-5 0 0,1 0 0,1 0 0,1 0 0,3 0 0,0 0 0,0 0-820,0 0 1,0 0 0,1 0 0,-1 0 769,3 0 0,0 0 0,-1 0 0,1 0 50,-2 0 0,0 0 0,0 0 0,-2 0 0,6 0 0,-1 0 0,0 0-39,1 0 0,0 0 0,-1 0 39,-4 0 0,-1 0 0,-1 0 278,-2 0 0,-1 0 0,-1 0-278,5 0 0,-2 0 0,3 0 0,-2 0 0,1 0 864,-1 0 0,2 0-864,4 0 516,-8 0 0,2 0-516,-3 0 0,-1 0 0,-5 0 0,0 0 0,6 0 0,-4 0 0,-7 0 0,14 0 0,-10 0 0,8 0 0,-3 0 0,0 0 0,6 0 0,-9 0 0,0 0 0,10 0 0,-15 0 0,12 0 0,-8 0 0,7 0 0,4 0 0,0 12 0,-4-9 0,5 9 0,-1-12 0,-4 17 0,-3-14 0,0-1 0,6 15 0,-6-10 0,0-2 0,-9-2 0,13 9 0,-26-12 0,26 0 0,-24 0 0,24 0 0,-14 0 0,0 12 0,14-10 0,-24 10 0,12-12 0,-5 18 0,-9-14 0,9 14 0,-12-18 0,11 0 0,-8 0 0,9 0 0,-12 0 0,0 0 0,0 0 0</inkml:trace>
+  <inkml:trace contextRef="#ctx0" brushRef="#br0" timeOffset="38700">2646 10160 24575,'30'0'0,"0"0"0,-1 0 0,1 0 0,1 0 0,1 0 0,0 0 0,1 0 0,-1 0 0,1 0 0,2 0-656,-3 0 1,2 0-1,0 0 1,0 0 0,-1 0 293,5 0 0,-1 1 1,-1-1-1,0-1 362,0-1 0,0-1 0,-1 0 0,-1-1 54,-1 1 1,-1 1 0,-1-2-1,-2-1-54,4-5 0,-2-2 0,-2 1 512,5 3 0,-2 0-512,-8-2 0,-2 2 0,10 8 0,-17 0 595,-4 0 0,-11 0 1,0 0-1</inkml:trace>
+</inkml:ink>
+</file>
+
+<file path=ppt/ink/ink12.xml><?xml version="1.0" encoding="utf-8"?>
+<inkml:ink xmlns:inkml="http://www.w3.org/2003/InkML">
+  <inkml:definitions>
+    <inkml:context xml:id="ctx0">
+      <inkml:inkSource xml:id="inkSrc0">
+        <inkml:traceFormat>
+          <inkml:channel name="X" type="integer" min="-2.14748E9" max="2.14748E9" units="cm"/>
+          <inkml:channel name="Y" type="integer" min="-2.14748E9" max="2.14748E9" units="cm"/>
+          <inkml:channel name="F" type="integer" max="32767" units="dev"/>
+        </inkml:traceFormat>
+        <inkml:channelProperties>
+          <inkml:channelProperty channel="X" name="resolution" value="1000" units="1/cm"/>
+          <inkml:channelProperty channel="Y" name="resolution" value="1000" units="1/cm"/>
+          <inkml:channelProperty channel="F" name="resolution" value="0" units="1/dev"/>
+        </inkml:channelProperties>
+      </inkml:inkSource>
+      <inkml:timestamp xml:id="ts0" timeString="2026-03-06T17:55:17.384"/>
+    </inkml:context>
+    <inkml:brush xml:id="br0">
+      <inkml:brushProperty name="width" value="0.05292" units="cm"/>
+      <inkml:brushProperty name="height" value="0.05292" units="cm"/>
+      <inkml:brushProperty name="color" value="#FF0000"/>
+    </inkml:brush>
+  </inkml:definitions>
+  <inkml:trace contextRef="#ctx0" brushRef="#br0">1191 12277 24575,'33'0'0,"0"0"0,-8 0 0,1 0 0,1 0 0,-1 0 0,1 0 0,1 0-735,2 0 0,0 0 1,2 0 734,4 0 0,1 0 0,0 0 0,-1 0 0,1 0 0,-1 0 0,-6 0 0,0 0 0,0 0 0,-1 0 0,7 0 0,-1 0 0,0 0 0,-2 0 0,1 0 0,-2 0 235,-5 0 1,-1 0 0,1 0-236,3 0 0,1 0 0,-2 0 0,3 0 0,-1 0 181,2 0 1,-1 0-182,-4 0 0,1 0 0,0 0 0,2 0 0,-1 0 0,7 0 0,1 0 0,-4 0 0,2 0 0,-5 0 0,-6 0 0,-1 0 0,6 1 0,2-2 0,-3-8 0,2 0 0,2 7 0,3 0-227,-7-4 0,2-1 0,-1 2 227,-3 4 0,0 1 0,-1 1 0,1-1 0,0 0 0,0 0 313,0 0 1,-1 0 0,-1 0-314,9 0 0,-2 0 0,-7 0 0,-1 0 0,-2 0 0,0 0 0,10 0 0,-12 0 0,0 0 358,1 0 0,-1 0-358,0 0 0,0 0 79,-1 0 0,0 0-79,9 0 0,-8 0 0,-8 0 0,0 18 0,20-14 0,-8 4 0,1 2 0,8-3 0,0-3 0,-8-2 0,-1-1 0,-1 6 0,-2-2 0,-7-5 0,-2 0 0</inkml:trace>
+  <inkml:trace contextRef="#ctx0" brushRef="#br0" timeOffset="11886">1892 5040 24575,'26'0'0,"0"0"0,0 0 0,4 0 0,0 0 0,2 0 0,-4 0 0,0 0 0,1 0 0,-1 0-556,9 0 0,-1 0 1,0 0 555,-2 0 0,-2 0 0,1 0 0,-2 0 0,-1 0 0,-2 0 270,-1 0 0,-2 0-270,5 0 0,-4 0 276,-12 0-276,-2 0 0,6 12 0,-14-9 851,14 9-851,-18-12 0,0 0 0,0 12 0,0-10 0,0 10 0,0-12 0</inkml:trace>
+  <inkml:trace contextRef="#ctx0" brushRef="#br0" timeOffset="26785">1389 7646 24575,'22'0'0,"0"0"0,2 0 0,1 0 0,4 0 0,2 0 0,-6 0 0,0 0 0,1 0-474,1 0 0,0 0 1,0 0 473,4 0 0,1 0 0,-1 0 0,2 0 0,0 0 0,0 0 0,1 0 0,1 0 0,0 0 0,-1 1 0,0-1 0,0-1 0,-5-2 0,0-2 0,1 2 0,6 1 0,2 2 0,-1-1 0,0-2 0,-1-1 0,0-1 0,-2-1 0,-1-1 0,0 2 0,1 4 0,-1 1 0,-6-3 462,1-15-462,2 18 235,-27 0-235,8 0 0,-11 0 0,18-11 724,10 8-724,-3-3 0,3 0 0,1 5 0,2 2 0,3-1 0,-2 0 0,5 0 0,-8 0 0,-29 0 0</inkml:trace>
+  <inkml:trace contextRef="#ctx0" brushRef="#br0" timeOffset="39316">1389 10107 24575,'22'-11'0,"0"0"0,5 4 0,3 1 0,3 1 0,-3 4 0,2 1 0,1 1 0,1-1-656,-1 0 1,2 0-1,0 0 1,1 0 0,-1 0 245,-1 0 1,0 0 0,0 0 0,1 0 0,1 0 409,-5 0 0,2 0 0,0 0 0,1 0 0,-1 0 0,0 0 0,-1 0 0,2 0 0,-1 0 0,0 0 0,-1 0 0,1 0 0,-1 0 0,1 0 0,0 0 0,1 0 0,-2 0 0,0 0 0,-2 0 0,6 0 0,-2 0 0,-1 0 0,-2 0 373,1 0 0,-3 0 1,0 0-374,6 0 0,-1 0 0,-8 0 0,1 0 0,-2 0 481,0 0 0,-2 0-481,3 0 0,-2 0 0,4 0 0,-7 0 0,-9 0 0</inkml:trace>
+</inkml:ink>
+</file>
+
+<file path=ppt/ink/ink13.xml><?xml version="1.0" encoding="utf-8"?>
+<inkml:ink xmlns:inkml="http://www.w3.org/2003/InkML">
+  <inkml:definitions>
+    <inkml:context xml:id="ctx0">
+      <inkml:inkSource xml:id="inkSrc0">
+        <inkml:traceFormat>
+          <inkml:channel name="X" type="integer" min="-2.14748E9" max="2.14748E9" units="cm"/>
+          <inkml:channel name="Y" type="integer" min="-2.14748E9" max="2.14748E9" units="cm"/>
+          <inkml:channel name="F" type="integer" max="32767" units="dev"/>
+        </inkml:traceFormat>
+        <inkml:channelProperties>
+          <inkml:channelProperty channel="X" name="resolution" value="1000" units="1/cm"/>
+          <inkml:channelProperty channel="Y" name="resolution" value="1000" units="1/cm"/>
+          <inkml:channelProperty channel="F" name="resolution" value="0" units="1/dev"/>
+        </inkml:channelProperties>
+      </inkml:inkSource>
+      <inkml:timestamp xml:id="ts0" timeString="2026-03-06T18:10:37.921"/>
+    </inkml:context>
+    <inkml:brush xml:id="br0">
+      <inkml:brushProperty name="width" value="0.05292" units="cm"/>
+      <inkml:brushProperty name="height" value="0.05292" units="cm"/>
+      <inkml:brushProperty name="color" value="#FF0000"/>
+    </inkml:brush>
+  </inkml:definitions>
+  <inkml:trace contextRef="#ctx0" brushRef="#br0">1138 6204 24575,'0'27'0,"0"5"0,0-4 0,0-9 0,0 0 0,0 9 0,0-7 0,0-9 0,0-1 0,0-8 0,0 27 0,0-26 0,0 26 0,0 2 0,0-1 0,0-6 0,0 0 0,0 3 0,0 4 0,0 0 0,0-4 0,0-7 0,0 2 0,0-20 0,0 27 0,0-14 0,0 2 0,0 2 0,0 8 0,0 4 0,0-9 0,0-2 0,0 10 0,2-4 0,-4-4 0,-16-6 0,14 12 0,-14-9 0,18 8 0,0-7 0,0 3 0,0-4 0,0-4 0,0 14 0,0-27 0,0 26 0,0-25 0,0 14 0,0-6 0,0 3 0,0-1 0,0 16 0,0-26 0,0 25 0,0-14 0,0 0 0,0 14 0,0-13 0,0 3 0,0 1 0,0 8 0,0 4 0,0 0 0,0-16 0,0 14 0,0-27 0,0 20 0,0-20 0,0 27 0,0-26 0,0 14 0,0-7 0,0 10 0,0-5 0,0 14 0,0-28 0,0 10 0,0 0 0,0-9 0,0 26 0,0-24 0,0 24 0,0-14 0,0 17 0,0-16 0,0 2 0,0-6 0,0-9 0,0 8 0,0 7 0,0-14 0,0 26 0,0-15 0,0 17 0,0-4 0,0-8 0,0-8 0,0-12 0,0 0 0</inkml:trace>
+  <inkml:trace contextRef="#ctx0" brushRef="#br0" timeOffset="6167">1442 7170 24575,'26'0'0,"-1"0"0,-1 0 0,1 0 0,-1 0 0,3 0 0,-2 0 0,6 0 0,2 0-693,1 1 0,3-1 0,-1-1 693,-8-2 0,0-2 0,1 1 0,0 3 0,2 1 0,0 0 0,0-1 0,-2-2 0,-1 0 0,0 0 0,0 0 0,9-1 0,-1-1 0,0 2 0,-2 2 0,-1 1 0,-1-2 0,-5-2 0,-1 0 0,-2 0 334,1 4 0,-1 0-334,7 0 0,0 0 171,-10 0 1,0 0-172,11 0 0,1 0 0,-2 0 0,-2 0 0,-3 2 0,-3-4 1068,9-15-1068,-2 12 0,-14-12 0,4 17 0,10 0 0,-14 0 0,16 0 0,1 0 0,-17 0 0,13 0 0,-14 0 0,-1 0 0,16 0 0,-26 0 0,14 0 0</inkml:trace>
+  <inkml:trace contextRef="#ctx0" brushRef="#br0" timeOffset="65968">13216 5913 24575,'0'34'0,"0"-5"0,0 4 0,0-7 0,0 2 0,0-1 0,0-1 0,0 0 0,0 1 0,0 5 0,0 1 0,0-4 0,0-4 0,0-1 0,0 4 0,0 1 0,0-2 0,0-1 0,0-5 0,0 1 0,0 8 0,0 1 0,0-6 0,0-1 0,0 0 0,0 0 0,0 2 0,0-2 0,0-4 0,0 0 0,0 6 0,0 1 0,1-3 0,-2 0 0,-5 5 0,0 0 0,5-8 0,-1-1 0,-4 0 0,0 0 0,7 4 0,-2 2 0,-7 3 0,-1 2 0,7-6 0,1 2 0,-1 2 0,-4 2 0,-2 2 0,-1 2 0,3 0 0,4 2 0,2 1 0,1 0 0,-3-2-381,-3-3 0,-2-1 0,1-1 0,1 1 381,3 4 0,2 0 0,0 0 0,-1-3 0,-3-2 0,-1-2 0,2 0 0,2 4 0,1 2 0,1-2 0,-1-5 0,0-1 0,0-1 0,0 4 0,0-3 0,0 6 0,0-1 0,-18-4 762,16-9 0,0 0-762,-16 9 0,18-7 0,0 2 0,0-20 0,0 26 0,0-24 0,0 12 0,0-17 0,0 12 0,0-9 0,0 9 0,0-12 0,0 0 0</inkml:trace>
+  <inkml:trace contextRef="#ctx0" brushRef="#br0" timeOffset="211850">4842 11324 24575,'34'0'0,"-10"0"0,2 0 0,-3 0 0,2 0 0,9 0 0,4 0 0,-3 0 0,1 0 0,-1 0 0,-3 0 0,1 0 0,-4 0 0,-8 0 0,-2 0 0,6 0 0,0 0 0,6 0 0,-6 0 0,0 0 0,3 0 0,-8 0 0,-8 0 0,-12 0 0,12 0 0,-9-12 0,26 9 0,-1-8 0,-3 10 0,3 2 0,7-1 0,2 0 0,-3 0 0,1 0 0,-9-4 0,0 0 0,0 0 0,8 3 0,-2-1 0,-7-4 0,-2 0 0,0 6 0,-1 0 0,10 0 0,-4 0 0,-9 0 0,0 0 0,9 0 0,4 0 0,-10 1 0,0-2 0,8-7 0,1-1 0,2 7 0,3-1-172,-7-6 0,2-3 1,-2 4 171,6 5 0,0 3 0,-6-4 0,2-1 0,-2 2 0,6 3 0,-1 0 0,-7 1 0,0 0 0,-3-3 0,2-7 0,-3 0 0,9 5 0,-8-14 0,-22 18 0,10 0 0,6 0 515,-14 0-515,26 0 0,-16 0 0,7 0 0,2 0 0,1 0 0,1 0 0,8 0 0,0 0 0,-8 0 0,-1 0 0,-1 0 0,-2 0 0,-7 0 0,16 0 0,-26 0 0,14 0 0,-18 0 0,12 0 0,-9 0 0,8 18 0,-11-14 0,0 14 0,0-18 0,0 12 0,0-9 0,0 9 0</inkml:trace>
+  <inkml:trace contextRef="#ctx0" brushRef="#br0" timeOffset="-159996.73">1958 12211 24575,'22'0'0,"0"0"0,5 0 0,4 0 0,1 0 0,3 0 0,3 0 0,0 0-820,-2 0 1,1 0 0,0 0 0,-1 0 805,-6 0 1,-1 0 0,1 0 0,1 0 13,4 0 0,2 0 0,0 0 0,0 0 0,-2 0 0,-2 0 0,-2 0 0,0 0 0,2 0 0,0 0 0,1 0 0,1 0 0,-1 0 0,-2 0 0,7 0 0,-3 0 0,-1 0 251,-3 0 1,-1 0 0,-1 0-252,2 0 0,-1 0 306,2 0 0,-5 0-306,-11 0 0,12 0 0,-26 11 1718,26-8-1718,-12 9 0,10-2 0,7-2 0,-8-6 0,0-1 0,3 0-715,3 3 0,2 1 0,1 0 0,2-1 715,-7-3 0,1 0 0,1-1 0,0 0 0,1-1 0,0 0-547,3-1 1,1-1 0,0 0 0,0-1 0,1 1 0,-1 0 496,-3 1 0,0 0 0,1 0 0,-1 0 0,1 0 0,-1-1 0,0 0 50,-1-1 0,1-1 0,-1 0 0,0 0 0,0 0 0,0 0 0,-1 2-313,1-1 1,0 1-1,0 1 1,-1 0-1,-1 0 1,1 0 312,3-1 0,0 0 0,-1 1 0,0 0 0,-2 0-186,1 1 0,-1 1 0,-1 1 0,0-1 186,7 0 0,-1 0 0,-2 0 537,-7 0 0,-2 0 0,1 0-537,2 0 0,2 0 0,-2 0 0,-1 1 0,-2-1 0,1-1 0,3-4 0,1-2 0,1 1 452,-3 5 0,2 1 0,0-1 1,0-1-453,1-4 0,0-3 0,0 1 0,1 2 0,2 3 0,0 3 0,0 0 0,1 0 0,-5-2 0,0 0 0,0 0 0,0-1 0,0 0 0,5-1 0,-1-1 0,0 0 0,0 1 0,-3 3 0,1 0 0,-1 1 0,0-2 0,3-2 0,1-1 0,-1 0 0,-1 1 0,3 3 0,-2 2 0,2-1 0,-6 0 0,2 1 0,0-1 0,0-1 0,2-1 0,0-1 0,-1-1 0,1 1 0,-3 2 0,-1 1 0,1 0 0,2-1 0,-3-2 0,1-1 0,2-1 0,0 0 0,-1 1 0,-2 1 0,6 1 0,-3 2 0,0 0 0,1-1 0,-2-1 0,2-1 0,0 0 0,-1 1 0,-3 0 0,4 2 0,-3 1 0,-1-2 639,0-4 0,-1-2 0,-1 2-639,5 2 0,1 1 0,-5-3 0,1-2 0,-2 2 0,-3 4 0,-1 2 550,7-1 1,-2 0-551,-2 0 521,4 0-521,-9 0 0,-2 0 1930,-2 0-1930,4 0 0,-5 0 462,-15 0-462,27 0 0,3 0 0,-9 0 0,1 0 0,7 0 0,1 0 0,-3 0 0,0 0 0,4-2 0,-2 4 0,-7 6 0,-1 1 0,-2-7 0,0 1 0,10 14 0,-16-17 0,2 0 0,-18 0 0,0 0 0,12 0 0,-9 12 0,8-9 0,7 9 0,-14-12 0,14 12 0,-18-10 0,0 10 0,0-12 0,-18 0 0,14 18 0,-14-14 0,18 14 0,0-18 0,0 0 0</inkml:trace>
+</inkml:ink>
+</file>
+
+<file path=ppt/ink/ink14.xml><?xml version="1.0" encoding="utf-8"?>
+<inkml:ink xmlns:inkml="http://www.w3.org/2003/InkML">
+  <inkml:definitions>
+    <inkml:context xml:id="ctx0">
+      <inkml:inkSource xml:id="inkSrc0">
+        <inkml:traceFormat>
+          <inkml:channel name="X" type="integer" min="-2.14748E9" max="2.14748E9" units="cm"/>
+          <inkml:channel name="Y" type="integer" min="-2.14748E9" max="2.14748E9" units="cm"/>
+          <inkml:channel name="F" type="integer" max="32767" units="dev"/>
+        </inkml:traceFormat>
+        <inkml:channelProperties>
+          <inkml:channelProperty channel="X" name="resolution" value="1000" units="1/cm"/>
+          <inkml:channelProperty channel="Y" name="resolution" value="1000" units="1/cm"/>
+          <inkml:channelProperty channel="F" name="resolution" value="0" units="1/dev"/>
+        </inkml:channelProperties>
+      </inkml:inkSource>
+      <inkml:timestamp xml:id="ts0" timeString="2026-03-09T16:37:30.210"/>
+    </inkml:context>
+    <inkml:brush xml:id="br0">
+      <inkml:brushProperty name="width" value="0.05292" units="cm"/>
+      <inkml:brushProperty name="height" value="0.05292" units="cm"/>
+      <inkml:brushProperty name="color" value="#FF0000"/>
+    </inkml:brush>
+  </inkml:definitions>
+  <inkml:trace contextRef="#ctx0" brushRef="#br0">15518 6615 24575,'15'0'0,"14"0"0,-25 0 0,14 0 0,-6 0 0,2 0 0,19 0 0,-5 11 0,-9-9 0,0-1 0,9 11 0,4-12 0,-17 0 0,14 0 0,-24 0 0,24 0 0,-26 0 0,21 0 0,-22 0 0,10 12 0,-12-9 0,18 9 0,-14-12 0,26 17 0,-10-12 0,-4 12 0,14-17 0,-27 0 0,9 0 0,-12 0 0,11 0 0,-8 0 0,9 0 0,6 0 0,-14 0 0,14 0 0,-7 0 0,-8 0 0,9 0 0,6 0 0,-14 0 0,26 0 0,2-17 0,-1 12 0,-9-10 0,0 1 0,10 11 0,-4-9 0,-7 12 0,8 0 0,-24-12 0,24 9 0,-14-8 0,17 11 0,-4 0 0,-8 0 0,4 0 0,-21 0 0,9-18 0,5 14 0,-12-14 0,24 18 0,-26 0 0,26 0 0,-24 0 0,24 0 0,-26 0 0,21 0 0,-21 0 0,8 0 0,7 0 0,-14 0 0,26 0 0,-27 0 0,9 0 0,-1 0 0,-8 0 0,27 0 0,-14 0 0,4 0 0,10 0 0,-26 0 0,14 18 0,-18-14 0,0 14 0</inkml:trace>
+  <inkml:trace contextRef="#ctx0" brushRef="#br0" timeOffset="8252">15042 7739 24575,'33'0'0,"-8"0"0,0 0 0,0 0 0,-1 0 0,0 0 0,0 0 0,7 0 0,0 0 0,-9 0 0,-1 0 0,5 0 0,1 0 0,2 0 0,-1 0 0,9 0 0,-15 0 0,0 0 0,10 0 0,-4 0 0,-7 0 0,2 0 0,-2 0 0,-5 0 0,13 0 0,-26 0 0,27 0 0,-14 0 0,4 0 0,4 0 0,-3 0 0,6 0 0,-6 0 0,3 0 0,-22 18 0,28-14 0,-14 14 0,5-18 0,8 0 0,-25 0 0,14 0 0,-6 0 0,-9 0 0,20 0 0,-2 0 0,7 0 0,-8 0 0,10 0 0,-14 0 0,5 0 0,2 0 0,-20 0 0,26 0 0,-24 0 0,24 0 0,-26 0 0,21 0 0,-4 0 0,-4 0 0,14 0 0,-10 0 0,8 0 0,-7 0 0,2 0 0,-2 0 0,7 0 0,4 0 0,1 0 0,-17 0 0,13 0 0,-26 0 0,26 0 0,-12 0 0,3 0 0,4 0 0,-4 0 0,8 0 0,5-18 0,-12 16 0,2 0 0,-5-7 0,0 0 0,16 9 0,-4 0 0,-27 0 0,20-12 0,-20 9 0,26-8 0,-12 11 0,1 0 0,2 0 0,8 0 0,4 0 0,0 0 0,-4 0 0,5 0 0,-1 0 0,-4 0 0,-8 0 0,-2 0 0,-2 0 0,14 0 0,-16 0 0,19 0 0,-17 0 0,13 0 0,-14 0 0,17 0 0,-15 0 0,12 0 0,-8 0 0,6-18 0,-6 14 0,3-14 0,-22 18 0,28-12 0,-26 9 0,26-9 0,-16 1 0,7 9 0,2 1 0,-4-4 0,-1-2 0,5-2 0,0 0 0,2 7 0,0 0 0,-1-7 0,0 0 0,0 8 0,1 2 0,7-1 0,-2 0 0,0 0 0,2-5 0,-2-1 0,-11 3 0,4-4 0,-5 2 0,-15 5 0,27 0 0,-26 0 0,14 0 0,-6 0 0,-10 0 0,22 0 0,-21 0 0,26 0 0,-24 0 0,12 0 0,-5 0 0,-9 0 0,21 0 0,-21 0 0,8 0 0,-11 0 0,18 0 0,-14 0 0,26 0 0,-10 0 0,8 0 0,-2 0 0,-2 0 0,-5 0 0,2 0 0,0 0 0,-7 0 0,1 0 0,-3 0 0,-12 0 0,17 0 0,-12 0 0,12 0 0,-17 0 0,0 0 0,12 12 0,-9-9 0,26 8 0,-24-11 0,24 0 0,-14 18 0,17-14 0,-4 14 0,-7-18 0,8 0 0,-24 12 0,12-9 0,-17 8 0,0-11 0,0 0 0</inkml:trace>
+  <inkml:trace contextRef="#ctx0" brushRef="#br0" timeOffset="43285">1548 11232 24575,'28'0'0,"0"0"0,-3 0 0,1 0 0,3 0 0,2 0 0,-1 0 0,5 0 0,-1 0 0,-8 0 0,0 0 0,0 0 0,4 0 0,0 0 0,3 0 0,-1 0 0,-11 0 0,0 0 0,5 0 0,-2 0 0,4 0 0,-9 0 0,0 0 0,2 0 0,-2 0 0,5 0 0,-2 0 0,-3 0 0,-15 0 0,14 0 0,-6 0 0,-9 0 0,20 0 0,-2 17 0,7-12 0,-8 12 0,10-5 0,-14-9 0,4 9 0,4-12 0,-21 0 0,26 0 0,-13 0 0,5 11 0,-9-8 0,-1 9 0,-8-12 0,27 0 0,-26 0 0,26 18 0,-27-14 0,26 14 0,-25-18 0,26 0 0,-27 0 0,20 0 0,-20 0 0,27 0 0,-26 0 0,14 0 0,-7 0 0,-8 0 0,27 0 0,-26 0 0,25 0 0,-14 12 0,0-9 0,14 8 0,-24-11 0,24 0 0,-14 0 0,17 0 0,-4 0 0,-9 0 0,0 0 0,9 0 0,-7 0 0,2 0 0,-20 0 0,27-11 0,-26 8 0,25-9 0,-14 12 0,17 0 0,-4 0 0,-7 0 0,8 0 0,-12 0 0,15 0 0,0 0 0,-16 0 0,14 0 0,-27 0 0,20 0 0,-2 0 0,7 0 0,-8 0 0,10 0 0,-14 0 0,16 0 0,-17 0 0,14 0 0,-12 0 0,1 0 0,2 0 0,8 0 0,4-18 0,0 14 0,-4-14 0,-7 18 0,2 0 0,-2 0 0,-5 0 0,14 0 0,-10 0 0,8 0 0,-7-12 0,2 9 0,-2-8 0,7 11 0,4 0 0,0 0 0,-4 0 0,-7 0 0,8 0 0,-13 0 0,5 0 0,2 0 0,-20 0 0,27 0 0,-14 0 0,5 0 0,2 0 0,-20 0 0,9 0 0,-12 0 0,0 0 0,0 0 0</inkml:trace>
+</inkml:ink>
+</file>
+
+<file path=ppt/ink/ink15.xml><?xml version="1.0" encoding="utf-8"?>
+<inkml:ink xmlns:inkml="http://www.w3.org/2003/InkML">
+  <inkml:definitions>
+    <inkml:context xml:id="ctx0">
+      <inkml:inkSource xml:id="inkSrc0">
+        <inkml:traceFormat>
+          <inkml:channel name="X" type="integer" min="-2.14748E9" max="2.14748E9" units="cm"/>
+          <inkml:channel name="Y" type="integer" min="-2.14748E9" max="2.14748E9" units="cm"/>
+          <inkml:channel name="F" type="integer" max="32767" units="dev"/>
+        </inkml:traceFormat>
+        <inkml:channelProperties>
+          <inkml:channelProperty channel="X" name="resolution" value="1000" units="1/cm"/>
+          <inkml:channelProperty channel="Y" name="resolution" value="1000" units="1/cm"/>
+          <inkml:channelProperty channel="F" name="resolution" value="0" units="1/dev"/>
+        </inkml:channelProperties>
+      </inkml:inkSource>
       <inkml:timestamp xml:id="ts0" timeString="2026-03-06T18:17:51.474"/>
     </inkml:context>
     <inkml:brush xml:id="br0">
@@ -971,6 +1206,125 @@
   <inkml:trace contextRef="#ctx0" brushRef="#br0">1098 5411 24575,'26'0'0,"0"0"0,0 0 0,6 0 0,1 0 0,0 0 0,3 0 0,1 0 0,-1 0-449,-7 0 1,-1 0 0,1 0-1,-2 0 449,6 0 0,-2 0 0,-2 0 0,3 0 0,-4 0 580,5 0-580,-4 0 296,-25 0-296,14 0 0,-6 0 0,8 0 918,8 0-918,5 0 0,-1 0 0,-16 0 0,2 0 0,-18 0 0</inkml:trace>
   <inkml:trace contextRef="#ctx0" brushRef="#br0" timeOffset="5062">1072 6548 24575,'26'0'0,"-1"0"0,1 0 0,9 0 0,0 0 0,-6 0 0,1 0 0,0 0-299,-3 0 1,0 0-1,0 0 299,0 0 0,1 0 0,-2 0 147,5 0 0,-2 0-147,-6 0 0,-2 0 74,1 0 1,0 0-75,7 0 0,3 0 0,-3 0 0,3 0 0,2 0 0,-1 0 0,2 0 0,-1 0 0,1 0-106,-4 0 1,1 0-1,-1 0 1,-3 0 105,6 0 0,-3 0 221,-1 0 1,-3 0-222,-2 0 0,-2 0 0,-5 0 0,-15 0 0,9 0 0</inkml:trace>
   <inkml:trace contextRef="#ctx0" brushRef="#br0" timeOffset="13466">939 7303 24575,'0'22'0,"0"0"0,0 6 0,0 4 0,0-2 0,0 4 0,0 0-820,0-4 1,0 1 0,0 1 0,0 2 496,0-2 0,0 2 0,0 0 0,0 1 0,0 0-147,0-3 1,0-1 0,0 1 0,0 1 0,0 0 0,0 0 469,0-1 0,0 1 0,0 0 0,0 0 0,0 1 0,0-1 0,0 0 0,0 0 0,0 0 0,0 0 0,0-1 0,0 1 0,0-1 0,0 0 0,0 2 0,0 0 0,0-1 0,0 1 0,0-1 0,0 0-51,0 2 1,0 0-1,0 0 1,0-1 0,0 0-1,0-2 51,0 4 0,0-2 0,0 0 0,0 1-277,0-3 1,0 1 0,0-1-1,0 1 1,0-3 276,0 2 0,0-2 0,0 0 0,0-1 272,0 0 0,0 0 0,0-1 0,0-1-272,0 5 0,0-2 0,0 1 0,0-1 0,0 0 0,0-1 1316,0 6 0,0 0-1316,0-6 0,0 1 0,0 0 0,0-3 0,0 0 0,0 0 0,0 4 0,0 0 0,0 0 0,0-4 0,0 0 0,0-1 0,0 9 0,0-3 1129,0-9 1,0-1-1130,0 11 2128,0-19-2128,0-2 841,0-12-841,0 18 0,0-14 0,0 14 0</inkml:trace>
+</inkml:ink>
+</file>
+
+<file path=ppt/ink/ink16.xml><?xml version="1.0" encoding="utf-8"?>
+<inkml:ink xmlns:inkml="http://www.w3.org/2003/InkML">
+  <inkml:definitions>
+    <inkml:context xml:id="ctx0">
+      <inkml:inkSource xml:id="inkSrc0">
+        <inkml:traceFormat>
+          <inkml:channel name="X" type="integer" min="-2.14748E9" max="2.14748E9" units="cm"/>
+          <inkml:channel name="Y" type="integer" min="-2.14748E9" max="2.14748E9" units="cm"/>
+          <inkml:channel name="F" type="integer" max="32767" units="dev"/>
+        </inkml:traceFormat>
+        <inkml:channelProperties>
+          <inkml:channelProperty channel="X" name="resolution" value="1000" units="1/cm"/>
+          <inkml:channelProperty channel="Y" name="resolution" value="1000" units="1/cm"/>
+          <inkml:channelProperty channel="F" name="resolution" value="0" units="1/dev"/>
+        </inkml:channelProperties>
+      </inkml:inkSource>
+      <inkml:timestamp xml:id="ts0" timeString="2026-03-09T16:39:01.561"/>
+    </inkml:context>
+    <inkml:brush xml:id="br0">
+      <inkml:brushProperty name="width" value="0.05292" units="cm"/>
+      <inkml:brushProperty name="height" value="0.05292" units="cm"/>
+      <inkml:brushProperty name="color" value="#FF0000"/>
+    </inkml:brush>
+  </inkml:definitions>
+  <inkml:trace contextRef="#ctx0" brushRef="#br0">529 4974 24575,'0'33'0,"0"-14"0,0 1 0,0 1 0,0-1 0,0 0 0,0 0 0,0 0 0,0-2 0,0 10 0,0 5 0,0-1 0,0-4 0,0 4 0,0 0 0,0-9 0,0 0 0,0 1 0,0 1 0,0 6 0,0 2 0,0-3 0,0 0 0,0 4 0,0-1 0,0-3 0,0 0 0,0 3 0,0-1 0,0-11 0,0 0 0,0 5 0,0-2 0,0 4 0,0-9 0,0 0 0,0 9 0,0-7 0,0-9 0,0-1 0,0-8 0,0 27 0,0-14 0,0 16 0,0 1 0,0-6 0,0-2 0,0 0 0,0 6 0,0-6 0,0 0 0,0-2 0,0 0 0,0 14 0,0-14 0,0-2 0,0-7 0,0 16 0,0-14 0,0 5 0,0-10 0,0-11 0,0 0 0</inkml:trace>
+</inkml:ink>
+</file>
+
+<file path=ppt/ink/ink17.xml><?xml version="1.0" encoding="utf-8"?>
+<inkml:ink xmlns:inkml="http://www.w3.org/2003/InkML">
+  <inkml:definitions>
+    <inkml:context xml:id="ctx0">
+      <inkml:inkSource xml:id="inkSrc0">
+        <inkml:traceFormat>
+          <inkml:channel name="X" type="integer" min="-2.14748E9" max="2.14748E9" units="cm"/>
+          <inkml:channel name="Y" type="integer" min="-2.14748E9" max="2.14748E9" units="cm"/>
+          <inkml:channel name="F" type="integer" max="32767" units="dev"/>
+        </inkml:traceFormat>
+        <inkml:channelProperties>
+          <inkml:channelProperty channel="X" name="resolution" value="1000" units="1/cm"/>
+          <inkml:channelProperty channel="Y" name="resolution" value="1000" units="1/cm"/>
+          <inkml:channelProperty channel="F" name="resolution" value="0" units="1/dev"/>
+        </inkml:channelProperties>
+      </inkml:inkSource>
+      <inkml:timestamp xml:id="ts0" timeString="2026-03-09T16:40:19.043"/>
+    </inkml:context>
+    <inkml:brush xml:id="br0">
+      <inkml:brushProperty name="width" value="0.05292" units="cm"/>
+      <inkml:brushProperty name="height" value="0.05292" units="cm"/>
+      <inkml:brushProperty name="color" value="#FF0000"/>
+    </inkml:brush>
+  </inkml:definitions>
+  <inkml:trace contextRef="#ctx0" brushRef="#br0">5252 4313 24575,'22'0'0,"-2"0"0,1 0 0,14 0 0,-6 0 0,3 0 0,-1-1 0,4 2 0,-7 1 0,3 1 0,0 1 0,-2-2 0,-2-1 0,-2-1 0,2 2 0,8 4 0,3 3 0,-1 0 0,-4-3 0,-2-4 0,-2 0 0,7 8 0,-3-2 0,0-8 0,-1 0 0,-16 0 0,13 0 0,4 0 0,-2 0 0,-6 0 0,0 0 0,3 0 0,4 12 0,-10-11 0,0 1 0,-4 4 0,1-1 0,9-4 0,1-2 0,-8 1 0,-1 0 0,0 0 0,0 0 0,12 0 0,1 0 0,-5 0 0,-10 0 0,2 0 0,-1 0 0,1 0 0,7 0 0,-1 0 0,-1 0 0,-1 0 0,5 0 0,-1 0 0,-7 0 0,-1 0 0,1 0 0,-2 0 0,13 0 0,-10 1 0,0-2 0,-3-4 0,-1-1 0,10 4 0,2 1 0,-3-5 0,-2 0 0,-3 5 0,-1 2 0,10-1 0,0 0 0,6 0 0,-14 0 0,-1 0 0,11 0 0,-11 1 0,0-2 0,8-17 0,-5 16 0,0 0 0,-2-7 0,0 0 0,9 8 0,2 2 0,0-1 0,1 0 0,-5 0 0,1 0 0,-2 0 0,3 1 0,-1-2 0,2-5 0,-1 0 0,-12 5 0,-1-1 0,7-4 0,-2 1 0,7 5 0,-6 0 0,0 0 0,3 0 0,-7 0 0,2 0 0,-2 0 0,7 0 0,-3 0 0,0 0 0,6 0 0,0 0 0,-1 0 0,1 0 0,-1 0 0,2 0 0,-7 0 0,-1 0 0,0 0 0,0 0 0,2 0 0,-2 0 0,4 0 0,-8 0 0,-2 0 0,-2 0 0,2 0 0,-18 0 0</inkml:trace>
+  <inkml:trace contextRef="#ctx0" brushRef="#br0" timeOffset="1735">8030 4061 24575,'15'0'0,"8"0"0,-2 0 0,7 0 0,-9 0 0,0 0 0,9 0 0,-7 0 0,2 0 0,-2 0 0,-5 0 0,13 0 0,-26 0 0,21 0 0,-4 0 0,-4 0 0,14 0 0,-10 0 0,8 0 0,-7 0 0,2 0 0,-2 0 0,-5 0 0,2 0 0</inkml:trace>
+  <inkml:trace contextRef="#ctx0" brushRef="#br0" timeOffset="30752">3400 8149 24575,'22'0'0,"0"0"0,9 0 0,-7 0 0,2 0 0,-3 0 0,-1 0 0,2 0 0,1 0 0,1 0 0,1 0 0,2 0 0,-1 0 0,-4 0 0,1 0 0,6 1 0,2-2 0,3-5 0,0 0 0,-1 5 0,-1-1 0,-8-1 0,1-2 0,-2 2 0,6 2 0,-1 2 0,2-1 0,0 0 0,-3 0 0,3 0 0,2 0 0,3 0 0,-1 0 0,-10 0 0,-2 0 0,2 0-134,3 0 0,3 0 0,-1 0 0,-4 0 134,6 0 0,-2 0 0,-6-1 0,1 1 0,-1 1 0,6 4 0,-2 1 0,-4-4 0,-1-1 0,2 4 0,-2 2 0,4 11 0,-9-16 0,0 0 0,9 16 0,-8-18 536,-8 0-536,-12 0 0,0 0 0,0 0 0</inkml:trace>
+  <inkml:trace contextRef="#ctx0" brushRef="#br0" timeOffset="33334">7938 7898 24575,'14'0'0,"-2"0"0,0 0 0,-9 0 0,26 0 0,-25 0 0,14 0 0,-18 0 0,12 12 0,3-9 0,5 3 0,4-1 0,0-5 0,0 0 0,0 9 0,1 0 0,1-7 0,-2 0 0,4 16 0,-8-18 0,-8 0 0,-12 0 0,0 0 0,0 12 0,0-9 0,0 8 0,0-11 0,0 18 0,0-14 0,0 14 0,12-18 0,-9 0 0,8 12 0,-11-9 0,0 9 0,0-12 0,0 11 0,0-8 0,0 9 0,0-12 0,0 0 0,0 18 0,-11-14 0,8 14 0,-9-18 0,12 0 0,0 0 0</inkml:trace>
+  <inkml:trace contextRef="#ctx0" brushRef="#br0" timeOffset="53734">2897 11933 24575,'22'0'0,"0"0"0,2 0 0,3 0 0,0 0 0,1 0 0,0 0 0,1 0-472,8 0 0,1 0 0,-2 0 472,-8 0 0,-1 0 0,-1 0 0,4 0 0,0 0 230,8 0 1,-3 0-231,-1 0 117,3 0 0,0 0-117,-1 0 0,-7-9 0,0 0 0,-8 7 0,-1 0 360,0-7 1,0 0-361,-2 8 0,2 2 0,4-1 0,4 1 0,1-2 0,1-2 0,0-2 0,2 1-309,-3 3 1,2 1-1,0-1 1,-1 0 308,8-2 0,-1-1 0,-2 0 0,-6-2 0,-2-1 0,-2 2 0,0 3 0,-2 0 0,1-8 0,-7 2 0,-14 8 0,27 0 0,-26 0 0,14 0 1234,-6 0-1234,2 0 0,19 0 0,-5 0 0,-4-6 0,2 0 0,-2 5 0,0-1 0,6-3 0,0-2 0,3 1 0,-1 1 0,-8 3 0,1 1 0,3-5 0,1 0 0,-8 6 0,-1 0 0,0-9 0,0 0 0,-1 7 0,0 0 0,9-16 0,-8 18 0,-8 0 0,0 0 0,-9 0 0,9 0 0,-12 18 0,0-14 0,0 14 0</inkml:trace>
+  <inkml:trace contextRef="#ctx0" brushRef="#br0" timeOffset="76418">3493 7779 24575,'32'0'0,"-4"0"0,-4 0 0,2 0 0,-2 0 0,0 0 0,0 0 0,1 0 0,6 0 0,-1 0 0,1 0 0,-5 5 0,-2 2 0,4-5 0,-7 10 0,2-12 0,-20 0 0,17 0 0,1 0 0,-13 0 0,14 0 0,3 0 0,-9 0 0,16 0 0,-17 12 0,14-9 0,-24 9 0,13-12 0,-18 0 0,11 0 0,-8 0 0,9 0 0,0 0 0,-9 0 0,26 0 0,-25 0 0,14 17 0,-6-12 0,-9 12 0,26-17 0,-24 0 0,24 0 0,-26 0 0,20 0 0,-20 0 0,27 0 0,-26 0 0,14 0 0,-6 0 0,-9 0 0,8 0 0,-11 12 0,0-9 0,0 9 0</inkml:trace>
+</inkml:ink>
+</file>
+
+<file path=ppt/ink/ink18.xml><?xml version="1.0" encoding="utf-8"?>
+<inkml:ink xmlns:inkml="http://www.w3.org/2003/InkML">
+  <inkml:definitions>
+    <inkml:context xml:id="ctx0">
+      <inkml:inkSource xml:id="inkSrc0">
+        <inkml:traceFormat>
+          <inkml:channel name="X" type="integer" min="-2.14748E9" max="2.14748E9" units="cm"/>
+          <inkml:channel name="Y" type="integer" min="-2.14748E9" max="2.14748E9" units="cm"/>
+          <inkml:channel name="F" type="integer" max="32767" units="dev"/>
+        </inkml:traceFormat>
+        <inkml:channelProperties>
+          <inkml:channelProperty channel="X" name="resolution" value="1000" units="1/cm"/>
+          <inkml:channelProperty channel="Y" name="resolution" value="1000" units="1/cm"/>
+          <inkml:channelProperty channel="F" name="resolution" value="0" units="1/dev"/>
+        </inkml:channelProperties>
+      </inkml:inkSource>
+      <inkml:timestamp xml:id="ts0" timeString="2026-03-09T16:43:30.294"/>
+    </inkml:context>
+    <inkml:brush xml:id="br0">
+      <inkml:brushProperty name="width" value="0.05292" units="cm"/>
+      <inkml:brushProperty name="height" value="0.05292" units="cm"/>
+      <inkml:brushProperty name="color" value="#FF0000"/>
+    </inkml:brush>
+  </inkml:definitions>
+  <inkml:trace contextRef="#ctx0" brushRef="#br0">1508 3493 24575,'0'22'0,"0"0"0,0 6 0,0 4 0,0-1 0,0 3 0,0-1-670,0 0 1,0-1 0,0 0 669,0 5 0,0 0 0,0 0 0,1-6 0,-1-1 0,-1 1 0,-2 6 0,-2 0 0,1-1 0,3-6 0,1-2 0,-2 0 0,-1-2 0,-2 0 0,2 0 238,3 5 0,0-1-238,-9 0 0,0 1 0,7-6 0,2 2 0,-2 1-314,-7 6 0,-3 1 1,3 1 313,7-9 0,1 0 0,2 1 0,-2 3 0,0-2 0,-1 3 0,0 1 0,0 1 0,0-1 0,0-3 0,-2 5 0,1-1 0,0-1 0,1 2-278,1-5 0,1 3 1,1 0-1,-1 0 0,0-2 1,-3-3 277,-6 8 0,-3-3 0,3-1 0,7 0 0,2-1 0,-2-1 269,-4-3 0,-1-1 1,2-1-270,5 6 0,0-2 57,-5-2 1,-1-1-58,4 3 0,1-1 629,-5-4 1,0 1-630,6 7 0,0 1 0,-6-3 0,0 0 0,5 3 0,-1 0 944,-4-3 1,0 0-945,6 3 0,0-1 34,0-10 0,0-1-34,0 5 0,0-2 0,0-8 0,0 1 0,0-5 0,0-9 0,0 9 0,0 5 0,0-12 0,0 24 0,-17 4 0,14-5 0,1 4 0,-3-3 0,-2 2 0,2 1-470,4-4 1,1 0 0,1 0 0,-1 2 469,-3 3 0,0 2 0,0 0 0,0 0 0,2 1 0,1 2 0,-1-1 0,0-1 0,-1-3 0,-1-1 0,0 0 0,-1 0 0,0-1 0,-1 1 0,0-2 0,2-1-98,1-1 1,1-1 0,-1-1 97,-3 1 0,-3 0 0,4-3 0,4 13 0,0-14 0,0-5 0,0-15 0,0 9 0,0-12 0,0 0 0</inkml:trace>
+  <inkml:trace contextRef="#ctx0" brushRef="#br0" timeOffset="8750">10014 4154 24575,'27'0'0,"-6"0"0,2 0 0,1 0 0,1 0 0,8 0 0,0 0 0,-9 0 0,0 0 0,8 0 0,-2 0 0,1 0 0,1 0 0,-10-1 0,-3 2 0,0 11 0,14-9 0,-4 8 0,-13-11 0,5 0 0,2 0 0,-20 0 0,9 0 0,-12 18 0,0-14 0,0 14 0</inkml:trace>
+  <inkml:trace contextRef="#ctx0" brushRef="#br0" timeOffset="12866">6046 4088 24575,'30'0'0,"0"0"0,-3 0 0,-1 0 0,0 0 0,-1 0 0,2 0 0,-1 0 0,-1 0 0,-1 0 0,-1 0 0,-1 0 0,4 0 0,-2 0 0,7 0 0,1 0 0,-2 0 0,-11 0 0,2 0 0,-1 0 0,1 0 0,7 0 0,-3 0 0,0 0 0,6 0 0,-6 0 0,0 0 0,2 0 0,6 0 0,-1 0 0,-4 0 0,4 0 0,1 0 0,-5 0 0,-9-6 0,0 0 0,9 3 0,4-9 0,-17 12 0,14 0 0,-1 0 0,-4 0 0,-3 0 0,-1 0 0,-4 0 0,3 0 0,0 0 0,-3 0 0,14 0 0,-27 0 0,20 0 0,-2 0 0,-5 0 0,13 0 0,-26 0 0,21 0 0,-4 0 0,-3 0 0,12 0 0,-8 0 0,-5 0 0,13 0 0,-14 0 0,17 0 0,-4 0 0,-9 0 0,0 0 0,9 0 0,-7 0 0,2 0 0,-2 0 0,-5 0 0,14 0 0,-16 0 0,1 0 0,14 0 0,-24 0 0,24 0 0,3 0 0,-1 0 0,-1 0 0,2 0 0,-7 0 0,-1 0 0,0 0 0,0 0 0,2 0 0,-2 0 0,4 0 0,4 0 0,1 0 0,-17 0 0,13 0 0,-26 0 0,21 0 0,-21 0 0,26-17 0,-13 12 0,2-4 0,2 1 0,0 7 0,0 2 0,1-1 0,-1 0 0,0 0 0,0 0 0,-1 0 0,0 0 0,9 0 0,-7 0 0,2 0 0,-20 0 0,27 0 0,-26 0 0,25 0 0,-14 0 0,0 0 0,-4 0 0,7 0 0,-13 0 0,24 0 0,-8 0 0,6 0 0,6 0 0,-19 0 0,16 0 0,-26 0 0,26 0 0,-27 0 0,8 0 0,-11 17 0,12-12 0,-9 12 0,9-17 0</inkml:trace>
+</inkml:ink>
+</file>
+
+<file path=ppt/ink/ink19.xml><?xml version="1.0" encoding="utf-8"?>
+<inkml:ink xmlns:inkml="http://www.w3.org/2003/InkML">
+  <inkml:definitions>
+    <inkml:context xml:id="ctx0">
+      <inkml:inkSource xml:id="inkSrc0">
+        <inkml:traceFormat>
+          <inkml:channel name="X" type="integer" min="-2.14748E9" max="2.14748E9" units="cm"/>
+          <inkml:channel name="Y" type="integer" min="-2.14748E9" max="2.14748E9" units="cm"/>
+          <inkml:channel name="F" type="integer" max="32767" units="dev"/>
+        </inkml:traceFormat>
+        <inkml:channelProperties>
+          <inkml:channelProperty channel="X" name="resolution" value="1000" units="1/cm"/>
+          <inkml:channelProperty channel="Y" name="resolution" value="1000" units="1/cm"/>
+          <inkml:channelProperty channel="F" name="resolution" value="0" units="1/dev"/>
+        </inkml:channelProperties>
+      </inkml:inkSource>
+      <inkml:timestamp xml:id="ts0" timeString="2026-03-09T16:44:16.159"/>
+    </inkml:context>
+    <inkml:brush xml:id="br0">
+      <inkml:brushProperty name="width" value="0.05292" units="cm"/>
+      <inkml:brushProperty name="height" value="0.05292" units="cm"/>
+      <inkml:brushProperty name="color" value="#FF0000"/>
+    </inkml:brush>
+  </inkml:definitions>
+  <inkml:trace contextRef="#ctx0" brushRef="#br0">2170 11800 24575,'33'0'0,"-8"0"0,0 0 0,-4 0 0,1 0 0,4 0 0,2 0 0,0 0-455,-2 0 1,-1 0 0,1 0 454,6 0 0,1 0 0,0 0 0,1 1 0,1-1 0,1-1 0,-6 0 0,2-2 0,0 0 0,-1-1 0,3-3 0,-2 0 0,1 0 0,4 2 0,0 0 0,-3-1 0,0-4 0,-2 2 222,-7 8 0,-2 0-222,0-5 0,-1-1 225,10 3-225,-13-3 0,2 0 0,4-1 0,2 2 0,9 4 0,1-1 0,-14-7 0,-1-2 0,2 2 0,1 6 0,2 4 0,-1-4 0,7-12 0,0 1 0,-3 12 0,0 1 0,2-14 0,1 1 0,2 11 0,2 1 0,-3-6 0,1-1 0,-10 4 0,1 1 0,1 1 0,-2 2 0,0 1 0,3-2 0,0-3 0,3-2 0,1 0 0,-1 2 0,3 3 0,-1 2 0,2-1-77,-2-1 1,2-2 0,0 1 0,-4 1 76,-3 1 0,-2 1 0,1 1 0,3-1 0,1 0 0,-2 0 0,0 0 0,-1 0 0,2 0 0,-3 0 0,6 0 0,-1 0 0,-4 0 0,-7 0 999,8 0-999,-25 0 0,26 0 0,-16 0 0,1 0 0,15 0 0,-26 0 0,25 0 0,-8 0 0,7 0 0,-4-1 0,2 2 0,-5 4 0,0 1 0,5-5 0,1 1 0,2 10 0,0 0 0,-5-10 0,0-1 0,8 4 0,1 2 0,-3 2 0,0-1 0,3-6 0,0 1 0,-3 11 0,1 1 0,-7-12 0,2-4 0,0 2-137,1 2 0,0 1 1,0 1 136,-2 1 0,0 0 0,1-1 0,7-3 0,1-1 0,-1 1 0,-7 3 0,-1 2 0,1-2 0,5-3 0,3-3 0,-1 0-355,2 1 1,0-1 0,-1 2 354,-2 3 0,0 0 0,0 0 0,5-3 0,1 0 0,-3 0 0,-8 3 0,-2 0 0,0 0-68,2-3 0,1-2 0,-1 1 68,4 0 0,-2 0 0,-4-1 0,-1 2 0,7 4 0,0 2 192,-7-6 0,0 1-192,9 4 0,0-1 536,-3-4 1,0-2-537,2 1 0,1 0 0,3 0 0,0 0 0,-1 0 0,-1 0 0,-8 0 0,1 0 0,-2 0 0,5 0 0,0 0 0,-3 0 0,1 0 0,0 0-155,-3 0 1,0 0 0,1 0 154,6 0 0,2 0 0,-1 0 0,-2 0 0,-1 0 0,1 0 0,0 0 0,0 0 0,0 0 0,-4 0 0,0 0 0,0 0 0,2 0 0,2 0 0,-2 0 0,-2 0 0,0 0 0,0 0 0,4 0 0,0 0 0,0 0 0,-4 0 0,0 0 0,0 0 0,2 0 0,2 0 0,-2 0 0,-2 0 0,0 0 0,0 0 0,3 0 0,1 0 0,1 0 0,0 0 0,1 0 0,0 0 0,-1 0 0,-1 0 0,0 0 0,-2 0 0,0 0 0,0 0 0,1 0 0,0 0 0,0 0 0,-3 0 0,-1 0 0,2 0 0,2 0 0,1 0 0,0 0 0,0 0 0,0 0 0,0 0 0,-1 0 0,1 0 0,0 0-378,6 0 0,0 0 0,0 0 378,-5 0 0,0 0 0,1 0 0,-4 0 0,2 0 0,1 0 0,-2 0 0,5 0 0,-1 0 0,-2 0 0,-5 0 0,-2 0 0,-1 0 0,10 0 0,-6 0 0,-13 0 0,14 0 0,-24 0 644,24 0-644,-26 0 1173,21 0-1173,-4 0 0,-4 0 0,2 0 0,-18 0 0</inkml:trace>
 </inkml:ink>
 </file>
 
@@ -1097,6 +1451,34 @@
           <inkml:channelProperty channel="F" name="resolution" value="0" units="1/dev"/>
         </inkml:channelProperties>
       </inkml:inkSource>
+      <inkml:timestamp xml:id="ts0" timeString="2026-03-09T16:33:08.778"/>
+    </inkml:context>
+    <inkml:brush xml:id="br0">
+      <inkml:brushProperty name="width" value="0.05292" units="cm"/>
+      <inkml:brushProperty name="height" value="0.05292" units="cm"/>
+      <inkml:brushProperty name="color" value="#FF0000"/>
+    </inkml:brush>
+  </inkml:definitions>
+  <inkml:trace contextRef="#ctx0" brushRef="#br0">4154 7488 24575,'26'0'0,"0"0"0,0 0 0,6 0 0,4 0 0,1 0 0,-2 0 0,1 0 0,-1 0 0,1 0-556,-3 0 0,1 0 0,0 0 1,-1 0 555,0 0 0,-1 0 0,-3 0 0,1 0 0,-2 0 356,9 0 0,-3 0-356,-14 0 0,0 0 183,5 0 1,0 0-184,6 0 0,-6 0 0,0 0 0,2 0 1144,6 0-1144,-1 0 0,-4 0 0,-9 0 0,0 0 0,9 0 0,-7 0 0,-9 0 0,-12 0 0</inkml:trace>
+</inkml:ink>
+</file>
+
+<file path=ppt/ink/ink6.xml><?xml version="1.0" encoding="utf-8"?>
+<inkml:ink xmlns:inkml="http://www.w3.org/2003/InkML">
+  <inkml:definitions>
+    <inkml:context xml:id="ctx0">
+      <inkml:inkSource xml:id="inkSrc0">
+        <inkml:traceFormat>
+          <inkml:channel name="X" type="integer" min="-2.14748E9" max="2.14748E9" units="cm"/>
+          <inkml:channel name="Y" type="integer" min="-2.14748E9" max="2.14748E9" units="cm"/>
+          <inkml:channel name="F" type="integer" max="32767" units="dev"/>
+        </inkml:traceFormat>
+        <inkml:channelProperties>
+          <inkml:channelProperty channel="X" name="resolution" value="1000" units="1/cm"/>
+          <inkml:channelProperty channel="Y" name="resolution" value="1000" units="1/cm"/>
+          <inkml:channelProperty channel="F" name="resolution" value="0" units="1/dev"/>
+        </inkml:channelProperties>
+      </inkml:inkSource>
       <inkml:timestamp xml:id="ts0" timeString="2026-03-06T17:42:36.040"/>
     </inkml:context>
     <inkml:brush xml:id="br0">
@@ -1113,7 +1495,35 @@
 </inkml:ink>
 </file>
 
-<file path=ppt/ink/ink6.xml><?xml version="1.0" encoding="utf-8"?>
+<file path=ppt/ink/ink7.xml><?xml version="1.0" encoding="utf-8"?>
+<inkml:ink xmlns:inkml="http://www.w3.org/2003/InkML">
+  <inkml:definitions>
+    <inkml:context xml:id="ctx0">
+      <inkml:inkSource xml:id="inkSrc0">
+        <inkml:traceFormat>
+          <inkml:channel name="X" type="integer" min="-2.14748E9" max="2.14748E9" units="cm"/>
+          <inkml:channel name="Y" type="integer" min="-2.14748E9" max="2.14748E9" units="cm"/>
+          <inkml:channel name="F" type="integer" max="32767" units="dev"/>
+        </inkml:traceFormat>
+        <inkml:channelProperties>
+          <inkml:channelProperty channel="X" name="resolution" value="1000" units="1/cm"/>
+          <inkml:channelProperty channel="Y" name="resolution" value="1000" units="1/cm"/>
+          <inkml:channelProperty channel="F" name="resolution" value="0" units="1/dev"/>
+        </inkml:channelProperties>
+      </inkml:inkSource>
+      <inkml:timestamp xml:id="ts0" timeString="2026-03-09T16:33:32.862"/>
+    </inkml:context>
+    <inkml:brush xml:id="br0">
+      <inkml:brushProperty name="width" value="0.05292" units="cm"/>
+      <inkml:brushProperty name="height" value="0.05292" units="cm"/>
+      <inkml:brushProperty name="color" value="#FF0000"/>
+    </inkml:brush>
+  </inkml:definitions>
+  <inkml:trace contextRef="#ctx0" brushRef="#br0">4154 5093 24575,'37'0'0,"-1"0"0,1 0 0,-1 0 0,0 0 0,1 0 0,-5 0 0,1 0 0,0 0 0,0 0 0,-2 0 0,0 0 0,-1 0 0,-2 0 0,10 0 0,-4 0 0,5 0 0,-7 0 0,-16 0 0,5 0 0,-10 18 0,-11-14 0,0 14 0,0-18 0,-11 0 0,-10 0 0,-7 12 0,4-11 0,-2 1 0,-3 12 0,-2 1 0,5-12 0,-1-3 0,-1 1-263,-2 5 1,-1 1-1,-1-2 263,1-4 0,0-2 0,1 1 0,2 3 0,1 2 0,1-1 0,-8-3 0,2 1 0,7 4 0,4 0 0,1-6 0,8 0 0,12 0 0,0 0 0,0 0 0</inkml:trace>
+</inkml:ink>
+</file>
+
+<file path=ppt/ink/ink8.xml><?xml version="1.0" encoding="utf-8"?>
 <inkml:ink xmlns:inkml="http://www.w3.org/2003/InkML">
   <inkml:definitions>
     <inkml:context xml:id="ctx0">
@@ -1141,66 +1551,6 @@
 </inkml:ink>
 </file>
 
-<file path=ppt/ink/ink7.xml><?xml version="1.0" encoding="utf-8"?>
-<inkml:ink xmlns:inkml="http://www.w3.org/2003/InkML">
-  <inkml:definitions>
-    <inkml:context xml:id="ctx0">
-      <inkml:inkSource xml:id="inkSrc0">
-        <inkml:traceFormat>
-          <inkml:channel name="X" type="integer" min="-2.14748E9" max="2.14748E9" units="cm"/>
-          <inkml:channel name="Y" type="integer" min="-2.14748E9" max="2.14748E9" units="cm"/>
-          <inkml:channel name="F" type="integer" max="32767" units="dev"/>
-        </inkml:traceFormat>
-        <inkml:channelProperties>
-          <inkml:channelProperty channel="X" name="resolution" value="1000" units="1/cm"/>
-          <inkml:channelProperty channel="Y" name="resolution" value="1000" units="1/cm"/>
-          <inkml:channelProperty channel="F" name="resolution" value="0" units="1/dev"/>
-        </inkml:channelProperties>
-      </inkml:inkSource>
-      <inkml:timestamp xml:id="ts0" timeString="2026-03-06T17:48:01.668"/>
-    </inkml:context>
-    <inkml:brush xml:id="br0">
-      <inkml:brushProperty name="width" value="0.05292" units="cm"/>
-      <inkml:brushProperty name="height" value="0.05292" units="cm"/>
-      <inkml:brushProperty name="color" value="#FF0000"/>
-    </inkml:brush>
-  </inkml:definitions>
-  <inkml:trace contextRef="#ctx0" brushRef="#br0">1442 5001 24575,'34'0'0,"-11"0"0,5 0 0,0 0 0,7 0 0,1 0 0,2 0-820,-2 0 1,2 0 0,0 0 0,0 0 667,-3 0 0,1 0 1,-1 0-1,0 0 152,1 0 0,0 0 0,-1 0 0,-2 0 239,-6 0 1,-1 0 0,0 0-240,6 0 0,0 0 0,-2 0 0,1 0 0,-2 0 0,5 0 0,-2 0 371,-7 0 0,-1 0-371,-1 0 0,-2 0 0,11 0 0,-12 0 0,0 0 1001,5 0 0,3 0-1001,1 0 0,2 0 0,-1 0 0,-2 0 0,0 0 0,2 0 0,3 0 0,-5 0 421,3 0-421,-7 0 0,2 0 0,2 0 0,1 0 0,-1 0 0,1 0 0,0 0 0,1 0 0,1 0 0,-1 0 0,1 0 0,0 0 0,-3 0 0,0 0 0,1 0 0,0 0 0,7 0 0,0 0 0,0 0 0,2 0 0,-1 0 0,-1 0 0,-8 0 0,-1 0 0,-2 0 0,6 0 0,-1 0 0,3 0 0,-5 0 0,-8 0 0,0 0 0,1 0 0,-1 0 0,13 0 0,3 0 0,-5 0 0,-1 0 0,1 0 0,-2 0 0,0 0 0,-29 0 0</inkml:trace>
-  <inkml:trace contextRef="#ctx0" brushRef="#br0" timeOffset="15616">979 10319 24575,'22'0'0,"0"0"0,2 0 0,1 0 0,4 0 0,2 0 0,1 0 0,1 0 0,2 0 0,2 0-229,-11 0 0,1 0 0,0 0 229,0 0 0,0 0 0,0 0 0,-1 0 0,0 0 0,0 0 0,4 0 0,1 0 0,-2 0 0,1 0 0,0 0 84,5 0 1,-1 0-85,-8 0 0,-2 0 0,0 0 0,1 0 0,-1 0 0,0 0 0,2 0 0,-2 0 0,4 0 259,-4 0 0,2 0-259,-5 0 0,1 0 0,3 0 0,3 0 0,1 0 0,3 0 0,1 0 0,2 0 0,-7 0 0,2 0 0,1 0 0,0 0 0,0 0 0,1 0 0,-1 0 0,0 0 0,1 0 0,0 0 0,-1 0 0,1 0 0,0 0 0,0 0 0,-1 0 0,1 0 0,1 0 0,-1 0 0,-2 0 0,-2 0 0,1 0 0,-3 0 0,1 0 0,8 0 0,1 0 0,-4 0 0,-8 0 0,0 0 0,4 0 0,3 0 0,0 0 0,2 0 0,1 0 0,0 0 0,-4 0 0,0 0 0,1 0 0,-1 0 0,0 0 0,1 0 0,-1 0 0,-2 0 0,-1 0 0,-2 0 0,0 0 0,8 0 0,-5 0 0,-13 0 0,-3 0 0,-12 0 0</inkml:trace>
-</inkml:ink>
-</file>
-
-<file path=ppt/ink/ink8.xml><?xml version="1.0" encoding="utf-8"?>
-<inkml:ink xmlns:inkml="http://www.w3.org/2003/InkML">
-  <inkml:definitions>
-    <inkml:context xml:id="ctx0">
-      <inkml:inkSource xml:id="inkSrc0">
-        <inkml:traceFormat>
-          <inkml:channel name="X" type="integer" min="-2.14748E9" max="2.14748E9" units="cm"/>
-          <inkml:channel name="Y" type="integer" min="-2.14748E9" max="2.14748E9" units="cm"/>
-          <inkml:channel name="F" type="integer" max="32767" units="dev"/>
-        </inkml:traceFormat>
-        <inkml:channelProperties>
-          <inkml:channelProperty channel="X" name="resolution" value="1000" units="1/cm"/>
-          <inkml:channelProperty channel="Y" name="resolution" value="1000" units="1/cm"/>
-          <inkml:channelProperty channel="F" name="resolution" value="0" units="1/dev"/>
-        </inkml:channelProperties>
-      </inkml:inkSource>
-      <inkml:timestamp xml:id="ts0" timeString="2026-03-06T17:55:17.384"/>
-    </inkml:context>
-    <inkml:brush xml:id="br0">
-      <inkml:brushProperty name="width" value="0.05292" units="cm"/>
-      <inkml:brushProperty name="height" value="0.05292" units="cm"/>
-      <inkml:brushProperty name="color" value="#FF0000"/>
-    </inkml:brush>
-  </inkml:definitions>
-  <inkml:trace contextRef="#ctx0" brushRef="#br0">1191 12277 24575,'33'0'0,"0"0"0,-8 0 0,1 0 0,1 0 0,-1 0 0,1 0 0,1 0-735,2 0 0,0 0 1,2 0 734,4 0 0,1 0 0,0 0 0,-1 0 0,1 0 0,-1 0 0,-6 0 0,0 0 0,0 0 0,-1 0 0,7 0 0,-1 0 0,0 0 0,-2 0 0,1 0 0,-2 0 235,-5 0 1,-1 0 0,1 0-236,3 0 0,1 0 0,-2 0 0,3 0 0,-1 0 181,2 0 1,-1 0-182,-4 0 0,1 0 0,0 0 0,2 0 0,-1 0 0,7 0 0,1 0 0,-4 0 0,2 0 0,-5 0 0,-6 0 0,-1 0 0,6 1 0,2-2 0,-3-8 0,2 0 0,2 7 0,3 0-227,-7-4 0,2-1 0,-1 2 227,-3 4 0,0 1 0,-1 1 0,1-1 0,0 0 0,0 0 313,0 0 1,-1 0 0,-1 0-314,9 0 0,-2 0 0,-7 0 0,-1 0 0,-2 0 0,0 0 0,10 0 0,-12 0 0,0 0 358,1 0 0,-1 0-358,0 0 0,0 0 79,-1 0 0,0 0-79,9 0 0,-8 0 0,-8 0 0,0 18 0,20-14 0,-8 4 0,1 2 0,8-3 0,0-3 0,-8-2 0,-1-1 0,-1 6 0,-2-2 0,-7-5 0,-2 0 0</inkml:trace>
-  <inkml:trace contextRef="#ctx0" brushRef="#br0" timeOffset="11886">1892 5040 24575,'26'0'0,"0"0"0,0 0 0,4 0 0,0 0 0,2 0 0,-4 0 0,0 0 0,1 0 0,-1 0-556,9 0 0,-1 0 1,0 0 555,-2 0 0,-2 0 0,1 0 0,-2 0 0,-1 0 0,-2 0 270,-1 0 0,-2 0-270,5 0 0,-4 0 276,-12 0-276,-2 0 0,6 12 0,-14-9 851,14 9-851,-18-12 0,0 0 0,0 12 0,0-10 0,0 10 0,0-12 0</inkml:trace>
-  <inkml:trace contextRef="#ctx0" brushRef="#br0" timeOffset="26785">1389 7646 24575,'22'0'0,"0"0"0,2 0 0,1 0 0,4 0 0,2 0 0,-6 0 0,0 0 0,1 0-474,1 0 0,0 0 1,0 0 473,4 0 0,1 0 0,-1 0 0,2 0 0,0 0 0,0 0 0,1 0 0,1 0 0,0 0 0,-1 1 0,0-1 0,0-1 0,-5-2 0,0-2 0,1 2 0,6 1 0,2 2 0,-1-1 0,0-2 0,-1-1 0,0-1 0,-2-1 0,-1-1 0,0 2 0,1 4 0,-1 1 0,-6-3 462,1-15-462,2 18 235,-27 0-235,8 0 0,-11 0 0,18-11 724,10 8-724,-3-3 0,3 0 0,1 5 0,2 2 0,3-1 0,-2 0 0,5 0 0,-8 0 0,-29 0 0</inkml:trace>
-  <inkml:trace contextRef="#ctx0" brushRef="#br0" timeOffset="39316">1389 10107 24575,'22'-11'0,"0"0"0,5 4 0,3 1 0,3 1 0,-3 4 0,2 1 0,1 1 0,1-1-656,-1 0 1,2 0-1,0 0 1,1 0 0,-1 0 245,-1 0 1,0 0 0,0 0 0,1 0 0,1 0 409,-5 0 0,2 0 0,0 0 0,1 0 0,-1 0 0,0 0 0,-1 0 0,2 0 0,-1 0 0,0 0 0,-1 0 0,1 0 0,-1 0 0,1 0 0,0 0 0,1 0 0,-2 0 0,0 0 0,-2 0 0,6 0 0,-2 0 0,-1 0 0,-2 0 373,1 0 0,-3 0 1,0 0-374,6 0 0,-1 0 0,-8 0 0,1 0 0,-2 0 481,0 0 0,-2 0-481,3 0 0,-2 0 0,4 0 0,-7 0 0,-9 0 0</inkml:trace>
-</inkml:ink>
-</file>
-
 <file path=ppt/ink/ink9.xml><?xml version="1.0" encoding="utf-8"?>
 <inkml:ink xmlns:inkml="http://www.w3.org/2003/InkML">
   <inkml:definitions>
@@ -1217,7 +1567,7 @@
           <inkml:channelProperty channel="F" name="resolution" value="0" units="1/dev"/>
         </inkml:channelProperties>
       </inkml:inkSource>
-      <inkml:timestamp xml:id="ts0" timeString="2026-03-06T18:10:37.921"/>
+      <inkml:timestamp xml:id="ts0" timeString="2026-03-09T16:33:38.027"/>
     </inkml:context>
     <inkml:brush xml:id="br0">
       <inkml:brushProperty name="width" value="0.05292" units="cm"/>
@@ -1225,11 +1575,7 @@
       <inkml:brushProperty name="color" value="#FF0000"/>
     </inkml:brush>
   </inkml:definitions>
-  <inkml:trace contextRef="#ctx0" brushRef="#br0">1138 6204 24575,'0'27'0,"0"5"0,0-4 0,0-9 0,0 0 0,0 9 0,0-7 0,0-9 0,0-1 0,0-8 0,0 27 0,0-26 0,0 26 0,0 2 0,0-1 0,0-6 0,0 0 0,0 3 0,0 4 0,0 0 0,0-4 0,0-7 0,0 2 0,0-20 0,0 27 0,0-14 0,0 2 0,0 2 0,0 8 0,0 4 0,0-9 0,0-2 0,0 10 0,2-4 0,-4-4 0,-16-6 0,14 12 0,-14-9 0,18 8 0,0-7 0,0 3 0,0-4 0,0-4 0,0 14 0,0-27 0,0 26 0,0-25 0,0 14 0,0-6 0,0 3 0,0-1 0,0 16 0,0-26 0,0 25 0,0-14 0,0 0 0,0 14 0,0-13 0,0 3 0,0 1 0,0 8 0,0 4 0,0 0 0,0-16 0,0 14 0,0-27 0,0 20 0,0-20 0,0 27 0,0-26 0,0 14 0,0-7 0,0 10 0,0-5 0,0 14 0,0-28 0,0 10 0,0 0 0,0-9 0,0 26 0,0-24 0,0 24 0,0-14 0,0 17 0,0-16 0,0 2 0,0-6 0,0-9 0,0 8 0,0 7 0,0-14 0,0 26 0,0-15 0,0 17 0,0-4 0,0-8 0,0-8 0,0-12 0,0 0 0</inkml:trace>
-  <inkml:trace contextRef="#ctx0" brushRef="#br0" timeOffset="6167">1442 7170 24575,'26'0'0,"-1"0"0,-1 0 0,1 0 0,-1 0 0,3 0 0,-2 0 0,6 0 0,2 0-693,1 1 0,3-1 0,-1-1 693,-8-2 0,0-2 0,1 1 0,0 3 0,2 1 0,0 0 0,0-1 0,-2-2 0,-1 0 0,0 0 0,0 0 0,9-1 0,-1-1 0,0 2 0,-2 2 0,-1 1 0,-1-2 0,-5-2 0,-1 0 0,-2 0 334,1 4 0,-1 0-334,7 0 0,0 0 171,-10 0 1,0 0-172,11 0 0,1 0 0,-2 0 0,-2 0 0,-3 2 0,-3-4 1068,9-15-1068,-2 12 0,-14-12 0,4 17 0,10 0 0,-14 0 0,16 0 0,1 0 0,-17 0 0,13 0 0,-14 0 0,-1 0 0,16 0 0,-26 0 0,14 0 0</inkml:trace>
-  <inkml:trace contextRef="#ctx0" brushRef="#br0" timeOffset="65968">13216 5913 24575,'0'34'0,"0"-5"0,0 4 0,0-7 0,0 2 0,0-1 0,0-1 0,0 0 0,0 1 0,0 5 0,0 1 0,0-4 0,0-4 0,0-1 0,0 4 0,0 1 0,0-2 0,0-1 0,0-5 0,0 1 0,0 8 0,0 1 0,0-6 0,0-1 0,0 0 0,0 0 0,0 2 0,0-2 0,0-4 0,0 0 0,0 6 0,0 1 0,1-3 0,-2 0 0,-5 5 0,0 0 0,5-8 0,-1-1 0,-4 0 0,0 0 0,7 4 0,-2 2 0,-7 3 0,-1 2 0,7-6 0,1 2 0,-1 2 0,-4 2 0,-2 2 0,-1 2 0,3 0 0,4 2 0,2 1 0,1 0 0,-3-2-381,-3-3 0,-2-1 0,1-1 0,1 1 381,3 4 0,2 0 0,0 0 0,-1-3 0,-3-2 0,-1-2 0,2 0 0,2 4 0,1 2 0,1-2 0,-1-5 0,0-1 0,0-1 0,0 4 0,0-3 0,0 6 0,0-1 0,-18-4 762,16-9 0,0 0-762,-16 9 0,18-7 0,0 2 0,0-20 0,0 26 0,0-24 0,0 12 0,0-17 0,0 12 0,0-9 0,0 9 0,0-12 0,0 0 0</inkml:trace>
-  <inkml:trace contextRef="#ctx0" brushRef="#br0" timeOffset="211850">4842 11324 24575,'34'0'0,"-10"0"0,2 0 0,-3 0 0,2 0 0,9 0 0,4 0 0,-3 0 0,1 0 0,-1 0 0,-3 0 0,1 0 0,-4 0 0,-8 0 0,-2 0 0,6 0 0,0 0 0,6 0 0,-6 0 0,0 0 0,3 0 0,-8 0 0,-8 0 0,-12 0 0,12 0 0,-9-12 0,26 9 0,-1-8 0,-3 10 0,3 2 0,7-1 0,2 0 0,-3 0 0,1 0 0,-9-4 0,0 0 0,0 0 0,8 3 0,-2-1 0,-7-4 0,-2 0 0,0 6 0,-1 0 0,10 0 0,-4 0 0,-9 0 0,0 0 0,9 0 0,4 0 0,-10 1 0,0-2 0,8-7 0,1-1 0,2 7 0,3-1-172,-7-6 0,2-3 1,-2 4 171,6 5 0,0 3 0,-6-4 0,2-1 0,-2 2 0,6 3 0,-1 0 0,-7 1 0,0 0 0,-3-3 0,2-7 0,-3 0 0,9 5 0,-8-14 0,-22 18 0,10 0 0,6 0 515,-14 0-515,26 0 0,-16 0 0,7 0 0,2 0 0,1 0 0,1 0 0,8 0 0,0 0 0,-8 0 0,-1 0 0,-1 0 0,-2 0 0,-7 0 0,16 0 0,-26 0 0,14 0 0,-18 0 0,12 0 0,-9 0 0,8 18 0,-11-14 0,0 14 0,0-18 0,0 12 0,0-9 0,0 9 0</inkml:trace>
-  <inkml:trace contextRef="#ctx0" brushRef="#br0" timeOffset="269500">1958 12211 24575,'22'0'0,"0"0"0,5 0 0,4 0 0,1 0 0,3 0 0,3 0 0,0 0-820,-2 0 1,1 0 0,0 0 0,-1 0 805,-6 0 1,-1 0 0,1 0 0,1 0 13,4 0 0,2 0 0,0 0 0,0 0 0,-2 0 0,-2 0 0,-2 0 0,0 0 0,2 0 0,0 0 0,1 0 0,1 0 0,-1 0 0,-2 0 0,7 0 0,-3 0 0,-1 0 251,-3 0 1,-1 0 0,-1 0-252,2 0 0,-1 0 306,2 0 0,-5 0-306,-11 0 0,12 0 0,-26 11 1718,26-8-1718,-12 9 0,10-2 0,7-2 0,-8-6 0,0-1 0,3 0-715,3 3 0,2 1 0,1 0 0,2-1 715,-7-3 0,1 0 0,1-1 0,0 0 0,1-1 0,0 0-547,3-1 1,1-1 0,0 0 0,0-1 0,1 1 0,-1 0 496,-3 1 0,0 0 0,1 0 0,-1 0 0,1 0 0,-1-1 0,0 0 50,-1-1 0,1-1 0,-1 0 0,0 0 0,0 0 0,0 0 0,-1 2-313,1-1 1,0 1-1,0 1 1,-1 0-1,-1 0 1,1 0 312,3-1 0,0 0 0,-1 1 0,0 0 0,-2 0-186,1 1 0,-1 1 0,-1 1 0,0-1 186,7 0 0,-1 0 0,-2 0 537,-7 0 0,-2 0 0,1 0-537,2 0 0,2 0 0,-2 0 0,-1 1 0,-2-1 0,1-1 0,3-4 0,1-2 0,1 1 452,-3 5 0,2 1 0,0-1 1,0-1-453,1-4 0,0-3 0,0 1 0,1 2 0,2 3 0,0 3 0,0 0 0,1 0 0,-5-2 0,0 0 0,0 0 0,0-1 0,0 0 0,5-1 0,-1-1 0,0 0 0,0 1 0,-3 3 0,1 0 0,-1 1 0,0-2 0,3-2 0,1-1 0,-1 0 0,-1 1 0,3 3 0,-2 2 0,2-1 0,-6 0 0,2 1 0,0-1 0,0-1 0,2-1 0,0-1 0,-1-1 0,1 1 0,-3 2 0,-1 1 0,1 0 0,2-1 0,-3-2 0,1-1 0,2-1 0,0 0 0,-1 1 0,-2 1 0,6 1 0,-3 2 0,0 0 0,1-1 0,-2-1 0,2-1 0,0 0 0,-1 1 0,-3 0 0,4 2 0,-3 1 0,-1-2 639,0-4 0,-1-2 0,-1 2-639,5 2 0,1 1 0,-5-3 0,1-2 0,-2 2 0,-3 4 0,-1 2 550,7-1 1,-2 0-551,-2 0 521,4 0-521,-9 0 0,-2 0 1930,-2 0-1930,4 0 0,-5 0 462,-15 0-462,27 0 0,3 0 0,-9 0 0,1 0 0,7 0 0,1 0 0,-3 0 0,0 0 0,4-2 0,-2 4 0,-7 6 0,-1 1 0,-2-7 0,0 1 0,10 14 0,-16-17 0,2 0 0,-18 0 0,0 0 0,12 0 0,-9 12 0,8-9 0,7 9 0,-14-12 0,14 12 0,-18-10 0,0 10 0,0-12 0,-18 0 0,14 18 0,-14-14 0,18 14 0,0-18 0,0 0 0</inkml:trace>
+  <inkml:trace contextRef="#ctx0" brushRef="#br0">3215 7924 24575,'33'0'0,"1"0"0,-1 0 0,0 0 0,-2 0 0,2 0 0,0 0 0,2 0 0,0 0 0,1 0 0,-3 0 0,1 0 0,0 0 0,1 0 0,1 0 0,0 0 0,1 0 0,1 0-328,-4 0 0,1 0 0,1 0 1,0 0-1,1 0 0,0 0 1,0 0-1,1 0 0,-1 0 1,0 0 29,-2 0 0,0 0 0,1 0 0,0 0 0,-1 0 0,1 0 0,0 0 0,0 0 1,0 0-1,0 0 0,0 0 0,0 0 0,0 0 0,0 0 0,1 0 0,-1 0 0,0 0 0,1 0 0,-1 0 1,0 0-1,0 0 0,0 0 0,-1 0 0,-1 0 0,1 0 0,-1 0 0,0 0 0,0 0 0,1 0 0,-1 0 1,0 0-1,0 0 0,1 0 264,-1 0 1,1 0-1,0 1 1,0-1 0,-1 0-1,1 0 1,0 0-1,-1 0 1,0 0 0,0 0-1,0-1 34,4 0 0,-1 0 0,0 0 0,-1 0 0,1 0 0,-1-1 0,0 1 0,1-1 0,0 1-48,0-1 0,0 1 0,1 0 0,-1-1 0,1 1 0,-1-1 0,0 1 0,-1-2 0,0 1 48,2-1 0,-1-1 0,0 0 0,-1 0 0,0-1 0,0 1 0,0 0 0,-1-1-197,3 1 1,0 0 0,0 1 0,-1-1-1,0 0 1,-1 0 0,0 0 196,-2-1 0,0 1 0,0 0 0,-1 0 0,-1-1 0,1 0 0,-2-1 239,2 0 1,0-2 0,-1 1-1,-1-1 1,0 0 0,0 1-240,4 0 0,0 0 0,-1 0 0,0-1 0,-1 0 650,3-3 1,-1-1-1,-1 0 1,2 2-651,-6 2 0,2 2 0,-1 0 0,0 0 0,-1-1 0,3-1 0,-1 0 0,0 0 0,1 0 421,-3 2 1,1 0-1,1 1 1,-1-1-1,0 1-421,6-1 0,0 1 0,-1 0 0,1 1 0,-5 1 0,0 0 0,0 1 0,0 0 0,-1 0 0,0-1 0,-1 1 0,0-1 0,1 1 0,0 0 0,3 1 0,2 1 0,-1 0 0,0-1 0,0 0 0,-3-1 0,-1 0 0,1-1 0,-1 0 0,0 1 0,1 2 0,0 0 0,-1 0 0,1 0 0,0 0 0,1 0 0,1 0 0,-1 0 0,1 0 0,-2 0 0,5 0 0,-2 0 0,1 0 0,0 0 0,-4 0 0,0 0 0,0 0 0,0 0 0,-1 0 0,4 0 0,0 0 0,-1 0 0,0 0 0,-1 0 0,0 0 0,0 0 0,-1 0 659,5 0 1,-2 0 0,2 0-660,-7 1 0,1 0 0,0-1 0,-1-2 0,4-3 0,-1-2 0,1 2 0,2 3 0,-1 1 0,0-1 685,-5-3 0,-1-2 0,-1 2-685,8 4 0,0 2 0,-4-1 0,0 0 0,4 0 0,0 0 0,-2 0 0,1 0 0,-5 0 0,0 0 0,0 0 0,-3 0 0,0 0 0,0 0 0,4 0 0,0 0 0,0 0 0,-4 0 0,-1 0 0,1 0 0,3 0 0,1 0 0,-2 0 0,6 0 0,-1 0 0,-4 0 0,0 0 0,0 0 0,5 0 0,-1 0 570,-4 0 0,0 0-570,2 0 0,-2 0 2225,1 0-2225,-7 0 0,2 0 718,-3 0 0,-1 0-718,15 0 150,-15 0 0,0 0-150,11 0 0,-6 0 0,6 0 0,-12 0 0,2 0 0,1 0 0,0 0 0,9 0 0,1 0 0,-4 0 0,0 0 0,2 0 0,1 0 0,2-1 0,2 2 0,-3 7 0,1 1 0,-1-7 0,-2 1 0,-8 6 0,-3-1 0,0-8 0,2 0 0,-20 0 0,9 12 0,-12-9 0,0 9-820,0-12 1,0 0 0,0 0 0</inkml:trace>
 </inkml:ink>
 </file>
 
@@ -4325,6 +4671,57 @@
           </a:p>
         </p:txBody>
       </p:sp>
+      <mc:AlternateContent xmlns:mc="http://schemas.openxmlformats.org/markup-compatibility/2006">
+        <mc:Choice xmlns:p14="http://schemas.microsoft.com/office/powerpoint/2010/main" Requires="p14">
+          <p:contentPart p14:bwMode="auto" r:id="rId3">
+            <p14:nvContentPartPr>
+              <p14:cNvPr id="9" name="Ink 8">
+                <a:extLst>
+                  <a:ext uri="{FF2B5EF4-FFF2-40B4-BE49-F238E27FC236}">
+                    <a16:creationId xmlns:a16="http://schemas.microsoft.com/office/drawing/2014/main" id="{AC7BE911-08F2-CEA2-B469-FE13315A8543}"/>
+                  </a:ext>
+                </a:extLst>
+              </p14:cNvPr>
+              <p14:cNvContentPartPr/>
+              <p14:nvPr/>
+            </p14:nvContentPartPr>
+            <p14:xfrm>
+              <a:off x="1495440" y="2695680"/>
+              <a:ext cx="386280" cy="360"/>
+            </p14:xfrm>
+          </p:contentPart>
+        </mc:Choice>
+        <mc:Fallback>
+          <p:pic>
+            <p:nvPicPr>
+              <p:cNvPr id="9" name="Ink 8">
+                <a:extLst>
+                  <a:ext uri="{FF2B5EF4-FFF2-40B4-BE49-F238E27FC236}">
+                    <a16:creationId xmlns:a16="http://schemas.microsoft.com/office/drawing/2014/main" id="{AC7BE911-08F2-CEA2-B469-FE13315A8543}"/>
+                  </a:ext>
+                </a:extLst>
+              </p:cNvPr>
+              <p:cNvPicPr/>
+              <p:nvPr/>
+            </p:nvPicPr>
+            <p:blipFill>
+              <a:blip r:embed="rId4"/>
+              <a:stretch>
+                <a:fillRect/>
+              </a:stretch>
+            </p:blipFill>
+            <p:spPr>
+              <a:xfrm>
+                <a:off x="1486080" y="2686320"/>
+                <a:ext cx="405000" cy="19080"/>
+              </a:xfrm>
+              <a:prstGeom prst="rect">
+                <a:avLst/>
+              </a:prstGeom>
+            </p:spPr>
+          </p:pic>
+        </mc:Fallback>
+      </mc:AlternateContent>
     </p:spTree>
   </p:cSld>
   <p:clrMapOvr>
@@ -5018,8 +5415,8 @@
           </a:p>
         </p:txBody>
       </p:sp>
-      <mc:AlternateContent xmlns:mc="http://schemas.openxmlformats.org/markup-compatibility/2006">
-        <mc:Choice xmlns:p14="http://schemas.microsoft.com/office/powerpoint/2010/main" Requires="p14">
+      <mc:AlternateContent xmlns:mc="http://schemas.openxmlformats.org/markup-compatibility/2006" xmlns:p14="http://schemas.microsoft.com/office/powerpoint/2010/main">
+        <mc:Choice Requires="p14">
           <p:contentPart p14:bwMode="auto" r:id="rId3">
             <p14:nvContentPartPr>
               <p14:cNvPr id="18" name="Ink 17">
@@ -5038,7 +5435,7 @@
             </p14:xfrm>
           </p:contentPart>
         </mc:Choice>
-        <mc:Fallback>
+        <mc:Fallback xmlns="">
           <p:pic>
             <p:nvPicPr>
               <p:cNvPr id="18" name="Ink 17">
@@ -5061,6 +5458,57 @@
               <a:xfrm>
                 <a:off x="966960" y="1586160"/>
                 <a:ext cx="5238720" cy="1514520"/>
+              </a:xfrm>
+              <a:prstGeom prst="rect">
+                <a:avLst/>
+              </a:prstGeom>
+            </p:spPr>
+          </p:pic>
+        </mc:Fallback>
+      </mc:AlternateContent>
+      <mc:AlternateContent xmlns:mc="http://schemas.openxmlformats.org/markup-compatibility/2006">
+        <mc:Choice xmlns:p14="http://schemas.microsoft.com/office/powerpoint/2010/main" Requires="p14">
+          <p:contentPart p14:bwMode="auto" r:id="rId5">
+            <p14:nvContentPartPr>
+              <p14:cNvPr id="19" name="Ink 18">
+                <a:extLst>
+                  <a:ext uri="{FF2B5EF4-FFF2-40B4-BE49-F238E27FC236}">
+                    <a16:creationId xmlns:a16="http://schemas.microsoft.com/office/drawing/2014/main" id="{5129E02F-C7EA-487F-74BE-96C2F5D0AE19}"/>
+                  </a:ext>
+                </a:extLst>
+              </p14:cNvPr>
+              <p14:cNvContentPartPr/>
+              <p14:nvPr/>
+            </p14:nvContentPartPr>
+            <p14:xfrm>
+              <a:off x="1495440" y="1833480"/>
+              <a:ext cx="238320" cy="48240"/>
+            </p14:xfrm>
+          </p:contentPart>
+        </mc:Choice>
+        <mc:Fallback>
+          <p:pic>
+            <p:nvPicPr>
+              <p:cNvPr id="19" name="Ink 18">
+                <a:extLst>
+                  <a:ext uri="{FF2B5EF4-FFF2-40B4-BE49-F238E27FC236}">
+                    <a16:creationId xmlns:a16="http://schemas.microsoft.com/office/drawing/2014/main" id="{5129E02F-C7EA-487F-74BE-96C2F5D0AE19}"/>
+                  </a:ext>
+                </a:extLst>
+              </p:cNvPr>
+              <p:cNvPicPr/>
+              <p:nvPr/>
+            </p:nvPicPr>
+            <p:blipFill>
+              <a:blip r:embed="rId6"/>
+              <a:stretch>
+                <a:fillRect/>
+              </a:stretch>
+            </p:blipFill>
+            <p:spPr>
+              <a:xfrm>
+                <a:off x="1486080" y="1824120"/>
+                <a:ext cx="257040" cy="66960"/>
               </a:xfrm>
               <a:prstGeom prst="rect">
                 <a:avLst/>
@@ -6664,8 +7112,8 @@
           </a:p>
         </p:txBody>
       </p:sp>
-      <mc:AlternateContent xmlns:mc="http://schemas.openxmlformats.org/markup-compatibility/2006">
-        <mc:Choice xmlns:p14="http://schemas.microsoft.com/office/powerpoint/2010/main" Requires="p14">
+      <mc:AlternateContent xmlns:mc="http://schemas.openxmlformats.org/markup-compatibility/2006" xmlns:p14="http://schemas.microsoft.com/office/powerpoint/2010/main">
+        <mc:Choice Requires="p14">
           <p:contentPart p14:bwMode="auto" r:id="rId3">
             <p14:nvContentPartPr>
               <p14:cNvPr id="9" name="Ink 8">
@@ -6684,7 +7132,7 @@
             </p14:xfrm>
           </p:contentPart>
         </mc:Choice>
-        <mc:Fallback>
+        <mc:Fallback xmlns="">
           <p:pic>
             <p:nvPicPr>
               <p:cNvPr id="9" name="Ink 8">
@@ -6707,6 +7155,57 @@
               <a:xfrm>
                 <a:off x="131400" y="2357280"/>
                 <a:ext cx="1011960" cy="257760"/>
+              </a:xfrm>
+              <a:prstGeom prst="rect">
+                <a:avLst/>
+              </a:prstGeom>
+            </p:spPr>
+          </p:pic>
+        </mc:Fallback>
+      </mc:AlternateContent>
+      <mc:AlternateContent xmlns:mc="http://schemas.openxmlformats.org/markup-compatibility/2006">
+        <mc:Choice xmlns:p14="http://schemas.microsoft.com/office/powerpoint/2010/main" Requires="p14">
+          <p:contentPart p14:bwMode="auto" r:id="rId5">
+            <p14:nvContentPartPr>
+              <p14:cNvPr id="13" name="Ink 12">
+                <a:extLst>
+                  <a:ext uri="{FF2B5EF4-FFF2-40B4-BE49-F238E27FC236}">
+                    <a16:creationId xmlns:a16="http://schemas.microsoft.com/office/drawing/2014/main" id="{EAAA24B4-E491-4956-13E3-5E7AE1EEF807}"/>
+                  </a:ext>
+                </a:extLst>
+              </p14:cNvPr>
+              <p14:cNvContentPartPr/>
+              <p14:nvPr/>
+            </p14:nvContentPartPr>
+            <p14:xfrm>
+              <a:off x="1157400" y="2695320"/>
+              <a:ext cx="3272040" cy="158040"/>
+            </p14:xfrm>
+          </p:contentPart>
+        </mc:Choice>
+        <mc:Fallback>
+          <p:pic>
+            <p:nvPicPr>
+              <p:cNvPr id="13" name="Ink 12">
+                <a:extLst>
+                  <a:ext uri="{FF2B5EF4-FFF2-40B4-BE49-F238E27FC236}">
+                    <a16:creationId xmlns:a16="http://schemas.microsoft.com/office/drawing/2014/main" id="{EAAA24B4-E491-4956-13E3-5E7AE1EEF807}"/>
+                  </a:ext>
+                </a:extLst>
+              </p:cNvPr>
+              <p:cNvPicPr/>
+              <p:nvPr/>
+            </p:nvPicPr>
+            <p:blipFill>
+              <a:blip r:embed="rId6"/>
+              <a:stretch>
+                <a:fillRect/>
+              </a:stretch>
+            </p:blipFill>
+            <p:spPr>
+              <a:xfrm>
+                <a:off x="1148040" y="2685960"/>
+                <a:ext cx="3290760" cy="176760"/>
               </a:xfrm>
               <a:prstGeom prst="rect">
                 <a:avLst/>
@@ -8365,8 +8864,8 @@
           </a:p>
         </p:txBody>
       </p:sp>
-      <mc:AlternateContent xmlns:mc="http://schemas.openxmlformats.org/markup-compatibility/2006">
-        <mc:Choice xmlns:p14="http://schemas.microsoft.com/office/powerpoint/2010/main" Requires="p14">
+      <mc:AlternateContent xmlns:mc="http://schemas.openxmlformats.org/markup-compatibility/2006" xmlns:p14="http://schemas.microsoft.com/office/powerpoint/2010/main">
+        <mc:Choice Requires="p14">
           <p:contentPart p14:bwMode="auto" r:id="rId3">
             <p14:nvContentPartPr>
               <p14:cNvPr id="10" name="Ink 9">
@@ -8385,7 +8884,7 @@
             </p14:xfrm>
           </p:contentPart>
         </mc:Choice>
-        <mc:Fallback>
+        <mc:Fallback xmlns="">
           <p:pic>
             <p:nvPicPr>
               <p:cNvPr id="10" name="Ink 9">
@@ -8408,6 +8907,57 @@
               <a:xfrm>
                 <a:off x="343080" y="1791000"/>
                 <a:ext cx="1128600" cy="1933560"/>
+              </a:xfrm>
+              <a:prstGeom prst="rect">
+                <a:avLst/>
+              </a:prstGeom>
+            </p:spPr>
+          </p:pic>
+        </mc:Fallback>
+      </mc:AlternateContent>
+      <mc:AlternateContent xmlns:mc="http://schemas.openxmlformats.org/markup-compatibility/2006">
+        <mc:Choice xmlns:p14="http://schemas.microsoft.com/office/powerpoint/2010/main" Requires="p14">
+          <p:contentPart p14:bwMode="auto" r:id="rId5">
+            <p14:nvContentPartPr>
+              <p14:cNvPr id="14" name="Ink 13">
+                <a:extLst>
+                  <a:ext uri="{FF2B5EF4-FFF2-40B4-BE49-F238E27FC236}">
+                    <a16:creationId xmlns:a16="http://schemas.microsoft.com/office/drawing/2014/main" id="{7AD861A7-21C7-3349-981F-691177BFFE29}"/>
+                  </a:ext>
+                </a:extLst>
+              </p14:cNvPr>
+              <p14:cNvContentPartPr/>
+              <p14:nvPr/>
+            </p14:nvContentPartPr>
+            <p14:xfrm>
+              <a:off x="542880" y="1790640"/>
+              <a:ext cx="871920" cy="1867680"/>
+            </p14:xfrm>
+          </p:contentPart>
+        </mc:Choice>
+        <mc:Fallback>
+          <p:pic>
+            <p:nvPicPr>
+              <p:cNvPr id="14" name="Ink 13">
+                <a:extLst>
+                  <a:ext uri="{FF2B5EF4-FFF2-40B4-BE49-F238E27FC236}">
+                    <a16:creationId xmlns:a16="http://schemas.microsoft.com/office/drawing/2014/main" id="{7AD861A7-21C7-3349-981F-691177BFFE29}"/>
+                  </a:ext>
+                </a:extLst>
+              </p:cNvPr>
+              <p:cNvPicPr/>
+              <p:nvPr/>
+            </p:nvPicPr>
+            <p:blipFill>
+              <a:blip r:embed="rId6"/>
+              <a:stretch>
+                <a:fillRect/>
+              </a:stretch>
+            </p:blipFill>
+            <p:spPr>
+              <a:xfrm>
+                <a:off x="533520" y="1781280"/>
+                <a:ext cx="890640" cy="1886400"/>
               </a:xfrm>
               <a:prstGeom prst="rect">
                 <a:avLst/>
@@ -9226,8 +9776,8 @@
           </a:p>
         </p:txBody>
       </p:sp>
-      <mc:AlternateContent xmlns:mc="http://schemas.openxmlformats.org/markup-compatibility/2006">
-        <mc:Choice xmlns:p14="http://schemas.microsoft.com/office/powerpoint/2010/main" Requires="p14">
+      <mc:AlternateContent xmlns:mc="http://schemas.openxmlformats.org/markup-compatibility/2006" xmlns:p14="http://schemas.microsoft.com/office/powerpoint/2010/main">
+        <mc:Choice Requires="p14">
           <p:contentPart p14:bwMode="auto" r:id="rId3">
             <p14:nvContentPartPr>
               <p14:cNvPr id="23" name="Ink 22">
@@ -9246,7 +9796,7 @@
             </p14:xfrm>
           </p:contentPart>
         </mc:Choice>
-        <mc:Fallback>
+        <mc:Fallback xmlns="">
           <p:pic>
             <p:nvPicPr>
               <p:cNvPr id="23" name="Ink 22">
@@ -10548,8 +11098,8 @@
           </a:fontRef>
         </p:style>
       </p:cxnSp>
-      <mc:AlternateContent xmlns:mc="http://schemas.openxmlformats.org/markup-compatibility/2006">
-        <mc:Choice xmlns:p14="http://schemas.microsoft.com/office/powerpoint/2010/main" Requires="p14">
+      <mc:AlternateContent xmlns:mc="http://schemas.openxmlformats.org/markup-compatibility/2006" xmlns:p14="http://schemas.microsoft.com/office/powerpoint/2010/main">
+        <mc:Choice Requires="p14">
           <p:contentPart p14:bwMode="auto" r:id="rId3">
             <p14:nvContentPartPr>
               <p14:cNvPr id="15" name="Ink 14">
@@ -10568,7 +11118,7 @@
             </p14:xfrm>
           </p:contentPart>
         </mc:Choice>
-        <mc:Fallback>
+        <mc:Fallback xmlns="">
           <p:pic>
             <p:nvPicPr>
               <p:cNvPr id="15" name="Ink 14">
@@ -10591,6 +11141,57 @@
               <a:xfrm>
                 <a:off x="385920" y="2119320"/>
                 <a:ext cx="4381920" cy="2310840"/>
+              </a:xfrm>
+              <a:prstGeom prst="rect">
+                <a:avLst/>
+              </a:prstGeom>
+            </p:spPr>
+          </p:pic>
+        </mc:Fallback>
+      </mc:AlternateContent>
+      <mc:AlternateContent xmlns:mc="http://schemas.openxmlformats.org/markup-compatibility/2006">
+        <mc:Choice xmlns:p14="http://schemas.microsoft.com/office/powerpoint/2010/main" Requires="p14">
+          <p:contentPart p14:bwMode="auto" r:id="rId5">
+            <p14:nvContentPartPr>
+              <p14:cNvPr id="19" name="Ink 18">
+                <a:extLst>
+                  <a:ext uri="{FF2B5EF4-FFF2-40B4-BE49-F238E27FC236}">
+                    <a16:creationId xmlns:a16="http://schemas.microsoft.com/office/drawing/2014/main" id="{E3572BDD-5ABF-438D-2C34-EF49AA69075D}"/>
+                  </a:ext>
+                </a:extLst>
+              </p14:cNvPr>
+              <p14:cNvContentPartPr/>
+              <p14:nvPr/>
+            </p14:nvContentPartPr>
+            <p14:xfrm>
+              <a:off x="557280" y="2367000"/>
+              <a:ext cx="6243840" cy="1733760"/>
+            </p14:xfrm>
+          </p:contentPart>
+        </mc:Choice>
+        <mc:Fallback>
+          <p:pic>
+            <p:nvPicPr>
+              <p:cNvPr id="19" name="Ink 18">
+                <a:extLst>
+                  <a:ext uri="{FF2B5EF4-FFF2-40B4-BE49-F238E27FC236}">
+                    <a16:creationId xmlns:a16="http://schemas.microsoft.com/office/drawing/2014/main" id="{E3572BDD-5ABF-438D-2C34-EF49AA69075D}"/>
+                  </a:ext>
+                </a:extLst>
+              </p:cNvPr>
+              <p:cNvPicPr/>
+              <p:nvPr/>
+            </p:nvPicPr>
+            <p:blipFill>
+              <a:blip r:embed="rId6"/>
+              <a:stretch>
+                <a:fillRect/>
+              </a:stretch>
+            </p:blipFill>
+            <p:spPr>
+              <a:xfrm>
+                <a:off x="547920" y="2357640"/>
+                <a:ext cx="6262560" cy="1752480"/>
               </a:xfrm>
               <a:prstGeom prst="rect">
                 <a:avLst/>
@@ -12973,8 +13574,8 @@
           </a:p>
         </p:txBody>
       </p:sp>
-      <mc:AlternateContent xmlns:mc="http://schemas.openxmlformats.org/markup-compatibility/2006">
-        <mc:Choice xmlns:p14="http://schemas.microsoft.com/office/powerpoint/2010/main" Requires="p14">
+      <mc:AlternateContent xmlns:mc="http://schemas.openxmlformats.org/markup-compatibility/2006" xmlns:p14="http://schemas.microsoft.com/office/powerpoint/2010/main">
+        <mc:Choice Requires="p14">
           <p:contentPart p14:bwMode="auto" r:id="rId3">
             <p14:nvContentPartPr>
               <p14:cNvPr id="56" name="Ink 55">
@@ -12993,7 +13594,7 @@
             </p14:xfrm>
           </p:contentPart>
         </mc:Choice>
-        <mc:Fallback>
+        <mc:Fallback xmlns="">
           <p:pic>
             <p:nvPicPr>
               <p:cNvPr id="56" name="Ink 55">
@@ -13016,6 +13617,57 @@
               <a:xfrm>
                 <a:off x="328680" y="1938600"/>
                 <a:ext cx="486000" cy="1743120"/>
+              </a:xfrm>
+              <a:prstGeom prst="rect">
+                <a:avLst/>
+              </a:prstGeom>
+            </p:spPr>
+          </p:pic>
+        </mc:Fallback>
+      </mc:AlternateContent>
+      <mc:AlternateContent xmlns:mc="http://schemas.openxmlformats.org/markup-compatibility/2006">
+        <mc:Choice xmlns:p14="http://schemas.microsoft.com/office/powerpoint/2010/main" Requires="p14">
+          <p:contentPart p14:bwMode="auto" r:id="rId5">
+            <p14:nvContentPartPr>
+              <p14:cNvPr id="57" name="Ink 56">
+                <a:extLst>
+                  <a:ext uri="{FF2B5EF4-FFF2-40B4-BE49-F238E27FC236}">
+                    <a16:creationId xmlns:a16="http://schemas.microsoft.com/office/drawing/2014/main" id="{9A8F4B0D-A76E-756F-5475-DEA03395924A}"/>
+                  </a:ext>
+                </a:extLst>
+              </p14:cNvPr>
+              <p14:cNvContentPartPr/>
+              <p14:nvPr/>
+            </p14:nvContentPartPr>
+            <p14:xfrm>
+              <a:off x="190440" y="1790640"/>
+              <a:ext cx="360" cy="543240"/>
+            </p14:xfrm>
+          </p:contentPart>
+        </mc:Choice>
+        <mc:Fallback>
+          <p:pic>
+            <p:nvPicPr>
+              <p:cNvPr id="57" name="Ink 56">
+                <a:extLst>
+                  <a:ext uri="{FF2B5EF4-FFF2-40B4-BE49-F238E27FC236}">
+                    <a16:creationId xmlns:a16="http://schemas.microsoft.com/office/drawing/2014/main" id="{9A8F4B0D-A76E-756F-5475-DEA03395924A}"/>
+                  </a:ext>
+                </a:extLst>
+              </p:cNvPr>
+              <p:cNvPicPr/>
+              <p:nvPr/>
+            </p:nvPicPr>
+            <p:blipFill>
+              <a:blip r:embed="rId6"/>
+              <a:stretch>
+                <a:fillRect/>
+              </a:stretch>
+            </p:blipFill>
+            <p:spPr>
+              <a:xfrm>
+                <a:off x="181080" y="1781280"/>
+                <a:ext cx="19080" cy="561960"/>
               </a:xfrm>
               <a:prstGeom prst="rect">
                 <a:avLst/>
@@ -13730,8 +14382,8 @@
           </a:p>
         </p:txBody>
       </p:sp>
-      <mc:AlternateContent xmlns:mc="http://schemas.openxmlformats.org/markup-compatibility/2006">
-        <mc:Choice xmlns:p14="http://schemas.microsoft.com/office/powerpoint/2010/main" Requires="p14">
+      <mc:AlternateContent xmlns:mc="http://schemas.openxmlformats.org/markup-compatibility/2006" xmlns:p14="http://schemas.microsoft.com/office/powerpoint/2010/main">
+        <mc:Choice Requires="p14">
           <p:contentPart p14:bwMode="auto" r:id="rId3">
             <p14:nvContentPartPr>
               <p14:cNvPr id="18" name="Ink 17">
@@ -13750,7 +14402,7 @@
             </p14:xfrm>
           </p:contentPart>
         </mc:Choice>
-        <mc:Fallback>
+        <mc:Fallback xmlns="">
           <p:pic>
             <p:nvPicPr>
               <p:cNvPr id="18" name="Ink 17">
@@ -14884,6 +15536,57 @@
           </a:p>
         </p:txBody>
       </p:sp>
+      <mc:AlternateContent xmlns:mc="http://schemas.openxmlformats.org/markup-compatibility/2006">
+        <mc:Choice xmlns:p14="http://schemas.microsoft.com/office/powerpoint/2010/main" Requires="p14">
+          <p:contentPart p14:bwMode="auto" r:id="rId3">
+            <p14:nvContentPartPr>
+              <p14:cNvPr id="24" name="Ink 23">
+                <a:extLst>
+                  <a:ext uri="{FF2B5EF4-FFF2-40B4-BE49-F238E27FC236}">
+                    <a16:creationId xmlns:a16="http://schemas.microsoft.com/office/drawing/2014/main" id="{E904D170-2237-656C-548A-35219327E92A}"/>
+                  </a:ext>
+                </a:extLst>
+              </p14:cNvPr>
+              <p14:cNvContentPartPr/>
+              <p14:nvPr/>
+            </p14:nvContentPartPr>
+            <p14:xfrm>
+              <a:off x="1042920" y="1461960"/>
+              <a:ext cx="2053080" cy="2834280"/>
+            </p14:xfrm>
+          </p:contentPart>
+        </mc:Choice>
+        <mc:Fallback>
+          <p:pic>
+            <p:nvPicPr>
+              <p:cNvPr id="24" name="Ink 23">
+                <a:extLst>
+                  <a:ext uri="{FF2B5EF4-FFF2-40B4-BE49-F238E27FC236}">
+                    <a16:creationId xmlns:a16="http://schemas.microsoft.com/office/drawing/2014/main" id="{E904D170-2237-656C-548A-35219327E92A}"/>
+                  </a:ext>
+                </a:extLst>
+              </p:cNvPr>
+              <p:cNvPicPr/>
+              <p:nvPr/>
+            </p:nvPicPr>
+            <p:blipFill>
+              <a:blip r:embed="rId4"/>
+              <a:stretch>
+                <a:fillRect/>
+              </a:stretch>
+            </p:blipFill>
+            <p:spPr>
+              <a:xfrm>
+                <a:off x="1033560" y="1452600"/>
+                <a:ext cx="2071800" cy="2853000"/>
+              </a:xfrm>
+              <a:prstGeom prst="rect">
+                <a:avLst/>
+              </a:prstGeom>
+            </p:spPr>
+          </p:pic>
+        </mc:Fallback>
+      </mc:AlternateContent>
     </p:spTree>
   </p:cSld>
   <p:clrMapOvr>
@@ -15295,6 +15998,57 @@
           </a:p>
         </p:txBody>
       </p:sp>
+      <mc:AlternateContent xmlns:mc="http://schemas.openxmlformats.org/markup-compatibility/2006">
+        <mc:Choice xmlns:p14="http://schemas.microsoft.com/office/powerpoint/2010/main" Requires="p14">
+          <p:contentPart p14:bwMode="auto" r:id="rId3">
+            <p14:nvContentPartPr>
+              <p14:cNvPr id="9" name="Ink 8">
+                <a:extLst>
+                  <a:ext uri="{FF2B5EF4-FFF2-40B4-BE49-F238E27FC236}">
+                    <a16:creationId xmlns:a16="http://schemas.microsoft.com/office/drawing/2014/main" id="{1224DAB0-4ED3-A392-16FF-892C26240B54}"/>
+                  </a:ext>
+                </a:extLst>
+              </p14:cNvPr>
+              <p14:cNvContentPartPr/>
+              <p14:nvPr/>
+            </p14:nvContentPartPr>
+            <p14:xfrm>
+              <a:off x="428760" y="1257480"/>
+              <a:ext cx="3376800" cy="1371960"/>
+            </p14:xfrm>
+          </p:contentPart>
+        </mc:Choice>
+        <mc:Fallback>
+          <p:pic>
+            <p:nvPicPr>
+              <p:cNvPr id="9" name="Ink 8">
+                <a:extLst>
+                  <a:ext uri="{FF2B5EF4-FFF2-40B4-BE49-F238E27FC236}">
+                    <a16:creationId xmlns:a16="http://schemas.microsoft.com/office/drawing/2014/main" id="{1224DAB0-4ED3-A392-16FF-892C26240B54}"/>
+                  </a:ext>
+                </a:extLst>
+              </p:cNvPr>
+              <p:cNvPicPr/>
+              <p:nvPr/>
+            </p:nvPicPr>
+            <p:blipFill>
+              <a:blip r:embed="rId4"/>
+              <a:stretch>
+                <a:fillRect/>
+              </a:stretch>
+            </p:blipFill>
+            <p:spPr>
+              <a:xfrm>
+                <a:off x="419400" y="1248120"/>
+                <a:ext cx="3395520" cy="1390680"/>
+              </a:xfrm>
+              <a:prstGeom prst="rect">
+                <a:avLst/>
+              </a:prstGeom>
+            </p:spPr>
+          </p:pic>
+        </mc:Fallback>
+      </mc:AlternateContent>
     </p:spTree>
   </p:cSld>
   <p:clrMapOvr>
@@ -16239,6 +16993,57 @@
           </a:p>
         </p:txBody>
       </p:sp>
+      <mc:AlternateContent xmlns:mc="http://schemas.openxmlformats.org/markup-compatibility/2006">
+        <mc:Choice xmlns:p14="http://schemas.microsoft.com/office/powerpoint/2010/main" Requires="p14">
+          <p:contentPart p14:bwMode="auto" r:id="rId3">
+            <p14:nvContentPartPr>
+              <p14:cNvPr id="5" name="Ink 4">
+                <a:extLst>
+                  <a:ext uri="{FF2B5EF4-FFF2-40B4-BE49-F238E27FC236}">
+                    <a16:creationId xmlns:a16="http://schemas.microsoft.com/office/drawing/2014/main" id="{7A369A67-4C74-B2D0-B0B4-512D2C96AB8D}"/>
+                  </a:ext>
+                </a:extLst>
+              </p14:cNvPr>
+              <p14:cNvContentPartPr/>
+              <p14:nvPr/>
+            </p14:nvContentPartPr>
+            <p14:xfrm>
+              <a:off x="781200" y="4147920"/>
+              <a:ext cx="2710080" cy="100800"/>
+            </p14:xfrm>
+          </p:contentPart>
+        </mc:Choice>
+        <mc:Fallback>
+          <p:pic>
+            <p:nvPicPr>
+              <p:cNvPr id="5" name="Ink 4">
+                <a:extLst>
+                  <a:ext uri="{FF2B5EF4-FFF2-40B4-BE49-F238E27FC236}">
+                    <a16:creationId xmlns:a16="http://schemas.microsoft.com/office/drawing/2014/main" id="{7A369A67-4C74-B2D0-B0B4-512D2C96AB8D}"/>
+                  </a:ext>
+                </a:extLst>
+              </p:cNvPr>
+              <p:cNvPicPr/>
+              <p:nvPr/>
+            </p:nvPicPr>
+            <p:blipFill>
+              <a:blip r:embed="rId4"/>
+              <a:stretch>
+                <a:fillRect/>
+              </a:stretch>
+            </p:blipFill>
+            <p:spPr>
+              <a:xfrm>
+                <a:off x="771840" y="4138560"/>
+                <a:ext cx="2728800" cy="119520"/>
+              </a:xfrm>
+              <a:prstGeom prst="rect">
+                <a:avLst/>
+              </a:prstGeom>
+            </p:spPr>
+          </p:pic>
+        </mc:Fallback>
+      </mc:AlternateContent>
     </p:spTree>
   </p:cSld>
   <p:clrMapOvr>
@@ -16632,8 +17437,8 @@
           </a:p>
         </p:txBody>
       </p:sp>
-      <mc:AlternateContent xmlns:mc="http://schemas.openxmlformats.org/markup-compatibility/2006">
-        <mc:Choice xmlns:p14="http://schemas.microsoft.com/office/powerpoint/2010/main" Requires="p14">
+      <mc:AlternateContent xmlns:mc="http://schemas.openxmlformats.org/markup-compatibility/2006" xmlns:p14="http://schemas.microsoft.com/office/powerpoint/2010/main">
+        <mc:Choice Requires="p14">
           <p:contentPart p14:bwMode="auto" r:id="rId3">
             <p14:nvContentPartPr>
               <p14:cNvPr id="11" name="Ink 10">
@@ -16652,7 +17457,7 @@
             </p14:xfrm>
           </p:contentPart>
         </mc:Choice>
-        <mc:Fallback>
+        <mc:Fallback xmlns="">
           <p:pic>
             <p:nvPicPr>
               <p:cNvPr id="11" name="Ink 10">
@@ -20056,8 +20861,8 @@
           </a:p>
         </p:txBody>
       </p:sp>
-      <mc:AlternateContent xmlns:mc="http://schemas.openxmlformats.org/markup-compatibility/2006">
-        <mc:Choice xmlns:p14="http://schemas.microsoft.com/office/powerpoint/2010/main" Requires="p14">
+      <mc:AlternateContent xmlns:mc="http://schemas.openxmlformats.org/markup-compatibility/2006" xmlns:p14="http://schemas.microsoft.com/office/powerpoint/2010/main">
+        <mc:Choice Requires="p14">
           <p:contentPart p14:bwMode="auto" r:id="rId3">
             <p14:nvContentPartPr>
               <p14:cNvPr id="43" name="Ink 42">
@@ -20076,7 +20881,7 @@
             </p14:xfrm>
           </p:contentPart>
         </mc:Choice>
-        <mc:Fallback>
+        <mc:Fallback xmlns="">
           <p:pic>
             <p:nvPicPr>
               <p:cNvPr id="43" name="Ink 42">
@@ -21303,8 +22108,8 @@
           </a:p>
         </p:txBody>
       </p:sp>
-      <mc:AlternateContent xmlns:mc="http://schemas.openxmlformats.org/markup-compatibility/2006">
-        <mc:Choice xmlns:p14="http://schemas.microsoft.com/office/powerpoint/2010/main" Requires="p14">
+      <mc:AlternateContent xmlns:mc="http://schemas.openxmlformats.org/markup-compatibility/2006" xmlns:p14="http://schemas.microsoft.com/office/powerpoint/2010/main">
+        <mc:Choice Requires="p14">
           <p:contentPart p14:bwMode="auto" r:id="rId3">
             <p14:nvContentPartPr>
               <p14:cNvPr id="8" name="Ink 7">
@@ -21323,7 +22128,7 @@
             </p14:xfrm>
           </p:contentPart>
         </mc:Choice>
-        <mc:Fallback>
+        <mc:Fallback xmlns="">
           <p:pic>
             <p:nvPicPr>
               <p:cNvPr id="8" name="Ink 7">

</xml_diff>